<commit_message>
Automate gold forecasting pipeline with Supabase
</commit_message>
<xml_diff>
--- a/UnivPractical.pptx
+++ b/UnivPractical.pptx
@@ -5,39 +5,40 @@
     <p:sldMasterId id="2147483648" r:id="rId1"/>
   </p:sldMasterIdLst>
   <p:notesMasterIdLst>
-    <p:notesMasterId r:id="rId16"/>
+    <p:notesMasterId r:id="rId17"/>
   </p:notesMasterIdLst>
   <p:sldIdLst>
     <p:sldId id="256" r:id="rId3"/>
-    <p:sldId id="257" r:id="rId4"/>
-    <p:sldId id="258" r:id="rId5"/>
-    <p:sldId id="259" r:id="rId6"/>
-    <p:sldId id="271" r:id="rId7"/>
-    <p:sldId id="272" r:id="rId8"/>
-    <p:sldId id="273" r:id="rId9"/>
-    <p:sldId id="274" r:id="rId10"/>
-    <p:sldId id="261" r:id="rId11"/>
-    <p:sldId id="280" r:id="rId12"/>
-    <p:sldId id="262" r:id="rId13"/>
-    <p:sldId id="281" r:id="rId14"/>
-    <p:sldId id="287" r:id="rId15"/>
-    <p:sldId id="282" r:id="rId17"/>
-    <p:sldId id="263" r:id="rId18"/>
-    <p:sldId id="264" r:id="rId19"/>
-    <p:sldId id="265" r:id="rId20"/>
-    <p:sldId id="266" r:id="rId21"/>
-    <p:sldId id="275" r:id="rId22"/>
-    <p:sldId id="276" r:id="rId23"/>
-    <p:sldId id="277" r:id="rId24"/>
-    <p:sldId id="286" r:id="rId25"/>
-    <p:sldId id="268" r:id="rId26"/>
-    <p:sldId id="284" r:id="rId27"/>
-    <p:sldId id="285" r:id="rId28"/>
-    <p:sldId id="269" r:id="rId29"/>
-    <p:sldId id="278" r:id="rId30"/>
-    <p:sldId id="279" r:id="rId31"/>
-    <p:sldId id="270" r:id="rId32"/>
-    <p:sldId id="288" r:id="rId33"/>
+    <p:sldId id="258" r:id="rId4"/>
+    <p:sldId id="257" r:id="rId5"/>
+    <p:sldId id="289" r:id="rId6"/>
+    <p:sldId id="259" r:id="rId7"/>
+    <p:sldId id="271" r:id="rId8"/>
+    <p:sldId id="272" r:id="rId9"/>
+    <p:sldId id="273" r:id="rId10"/>
+    <p:sldId id="274" r:id="rId11"/>
+    <p:sldId id="261" r:id="rId12"/>
+    <p:sldId id="280" r:id="rId13"/>
+    <p:sldId id="262" r:id="rId14"/>
+    <p:sldId id="281" r:id="rId15"/>
+    <p:sldId id="287" r:id="rId16"/>
+    <p:sldId id="282" r:id="rId18"/>
+    <p:sldId id="263" r:id="rId19"/>
+    <p:sldId id="264" r:id="rId20"/>
+    <p:sldId id="265" r:id="rId21"/>
+    <p:sldId id="266" r:id="rId22"/>
+    <p:sldId id="275" r:id="rId23"/>
+    <p:sldId id="276" r:id="rId24"/>
+    <p:sldId id="277" r:id="rId25"/>
+    <p:sldId id="286" r:id="rId26"/>
+    <p:sldId id="268" r:id="rId27"/>
+    <p:sldId id="284" r:id="rId28"/>
+    <p:sldId id="285" r:id="rId29"/>
+    <p:sldId id="269" r:id="rId30"/>
+    <p:sldId id="278" r:id="rId31"/>
+    <p:sldId id="279" r:id="rId32"/>
+    <p:sldId id="270" r:id="rId33"/>
+    <p:sldId id="288" r:id="rId34"/>
   </p:sldIdLst>
   <p:sldSz cx="12192000" cy="6858000"/>
   <p:notesSz cx="6858000" cy="9144000"/>
@@ -5647,6 +5648,315 @@
       <p:grpSpPr/>
       <p:sp>
         <p:nvSpPr>
+          <p:cNvPr id="10242" name="Title 1"/>
+          <p:cNvSpPr>
+            <a:spLocks noGrp="1"/>
+          </p:cNvSpPr>
+          <p:nvPr>
+            <p:ph type="title"/>
+          </p:nvPr>
+        </p:nvSpPr>
+        <p:spPr>
+          <a:xfrm>
+            <a:off x="838200" y="1296988"/>
+            <a:ext cx="10515600" cy="708025"/>
+          </a:xfrm>
+        </p:spPr>
+        <p:txBody>
+          <a:bodyPr vert="horz" wrap="square" lIns="91440" tIns="45720" rIns="91440" bIns="45720" anchor="ctr" anchorCtr="0"/>
+          <a:p>
+            <a:pPr>
+              <a:buNone/>
+            </a:pPr>
+            <a:br>
+              <a:rPr lang="en-IN" altLang="x-none" dirty="0">
+                <a:latin typeface="Times New Roman" panose="02020603050405020304" pitchFamily="18" charset="0"/>
+                <a:cs typeface="Times New Roman" panose="02020603050405020304" pitchFamily="18" charset="0"/>
+              </a:rPr>
+            </a:br>
+            <a:r>
+              <a:rPr lang="en-IN" altLang="x-none" dirty="0">
+                <a:latin typeface="Times New Roman" panose="02020603050405020304" pitchFamily="18" charset="0"/>
+                <a:cs typeface="Times New Roman" panose="02020603050405020304" pitchFamily="18" charset="0"/>
+              </a:rPr>
+              <a:t>Existing System</a:t>
+            </a:r>
+            <a:endParaRPr lang="en-IN" altLang="x-none" dirty="0">
+              <a:latin typeface="Times New Roman" panose="02020603050405020304" pitchFamily="18" charset="0"/>
+              <a:ea typeface="Times New Roman" panose="02020603050405020304" pitchFamily="18" charset="0"/>
+            </a:endParaRPr>
+          </a:p>
+        </p:txBody>
+      </p:sp>
+      <p:sp>
+        <p:nvSpPr>
+          <p:cNvPr id="10243" name="Content Placeholder 2"/>
+          <p:cNvSpPr>
+            <a:spLocks noGrp="1"/>
+          </p:cNvSpPr>
+          <p:nvPr>
+            <p:ph idx="1"/>
+          </p:nvPr>
+        </p:nvSpPr>
+        <p:spPr>
+          <a:xfrm>
+            <a:off x="838200" y="2499360"/>
+            <a:ext cx="10515600" cy="4552950"/>
+          </a:xfrm>
+        </p:spPr>
+        <p:txBody>
+          <a:bodyPr vert="horz" wrap="square" lIns="91440" tIns="45720" rIns="91440" bIns="45720" anchor="t" anchorCtr="0"/>
+          <a:p>
+            <a:r>
+              <a:rPr lang="en-US" altLang="en-US" sz="2000" dirty="0">
+                <a:latin typeface="Times New Roman" panose="02020603050405020304" pitchFamily="18" charset="0"/>
+                <a:ea typeface="Times New Roman" panose="02020603050405020304" pitchFamily="18" charset="0"/>
+              </a:rPr>
+              <a:t>Current gold price prediction primarily uses traditional statistical methods and elementary machine learning models, such as moving averages and ARIMA, which assume linear and stationary market behavior due to their simplicity and interpretability.</a:t>
+            </a:r>
+            <a:endParaRPr lang="en-US" altLang="en-US" sz="2000" dirty="0">
+              <a:latin typeface="Times New Roman" panose="02020603050405020304" pitchFamily="18" charset="0"/>
+              <a:ea typeface="Times New Roman" panose="02020603050405020304" pitchFamily="18" charset="0"/>
+            </a:endParaRPr>
+          </a:p>
+          <a:p>
+            <a:r>
+              <a:rPr lang="en-US" altLang="en-US" sz="2000" dirty="0">
+                <a:latin typeface="Times New Roman" panose="02020603050405020304" pitchFamily="18" charset="0"/>
+                <a:ea typeface="Times New Roman" panose="02020603050405020304" pitchFamily="18" charset="0"/>
+              </a:rPr>
+              <a:t>These legacy approaches suffer from significant limitations, including manual and repetitive data gathering, non-automated model retraining, and a high risk of human error, consuming valuable time and resources.</a:t>
+            </a:r>
+            <a:endParaRPr lang="en-US" altLang="en-US" sz="2000" dirty="0">
+              <a:latin typeface="Times New Roman" panose="02020603050405020304" pitchFamily="18" charset="0"/>
+              <a:ea typeface="Times New Roman" panose="02020603050405020304" pitchFamily="18" charset="0"/>
+            </a:endParaRPr>
+          </a:p>
+          <a:p>
+            <a:r>
+              <a:rPr lang="en-US" altLang="en-US" sz="2000" dirty="0">
+                <a:latin typeface="Times New Roman" panose="02020603050405020304" pitchFamily="18" charset="0"/>
+                <a:ea typeface="Times New Roman" panose="02020603050405020304" pitchFamily="18" charset="0"/>
+              </a:rPr>
+              <a:t>Furthermore, these methods are generally limited to short-term forecasts, perform poorly in volatile markets, lack robustness against unexpected events, and are unsuitable for handling increasing data volumes or providing meaningful visualization and decision support.</a:t>
+            </a:r>
+            <a:endParaRPr lang="en-US" altLang="en-US" sz="2000" dirty="0">
+              <a:latin typeface="Times New Roman" panose="02020603050405020304" pitchFamily="18" charset="0"/>
+              <a:ea typeface="Times New Roman" panose="02020603050405020304" pitchFamily="18" charset="0"/>
+            </a:endParaRPr>
+          </a:p>
+        </p:txBody>
+      </p:sp>
+      <p:sp>
+        <p:nvSpPr>
+          <p:cNvPr id="4" name="Slide Number Placeholder 3"/>
+          <p:cNvSpPr txBox="1">
+            <a:spLocks noGrp="1"/>
+          </p:cNvSpPr>
+          <p:nvPr>
+            <p:ph type="sldNum" sz="quarter" idx="12"/>
+          </p:nvPr>
+        </p:nvSpPr>
+        <p:spPr>
+          <a:noFill/>
+        </p:spPr>
+        <p:txBody>
+          <a:bodyPr vert="horz" lIns="91440" tIns="45720" rIns="91440" bIns="45720" rtlCol="0" anchor="ctr"/>
+          <a:lstStyle>
+            <a:lvl1pPr marL="0" lvl="0" indent="0" algn="l" defTabSz="914400" rtl="0" eaLnBrk="1" fontAlgn="base" latinLnBrk="0" hangingPunct="1">
+              <a:lnSpc>
+                <a:spcPct val="100000"/>
+              </a:lnSpc>
+              <a:spcBef>
+                <a:spcPct val="0"/>
+              </a:spcBef>
+              <a:spcAft>
+                <a:spcPct val="0"/>
+              </a:spcAft>
+              <a:buNone/>
+              <a:defRPr sz="1800" b="0" i="0" u="none" kern="1200" baseline="0">
+                <a:solidFill>
+                  <a:schemeClr val="tx1"/>
+                </a:solidFill>
+                <a:latin typeface="Calibri" panose="020F0502020204030204" pitchFamily="34" charset="0"/>
+              </a:defRPr>
+            </a:lvl1pPr>
+            <a:lvl2pPr marL="457200" lvl="1" indent="0" algn="l" defTabSz="914400" rtl="0" eaLnBrk="1" fontAlgn="base" latinLnBrk="0" hangingPunct="1">
+              <a:lnSpc>
+                <a:spcPct val="100000"/>
+              </a:lnSpc>
+              <a:spcBef>
+                <a:spcPct val="0"/>
+              </a:spcBef>
+              <a:spcAft>
+                <a:spcPct val="0"/>
+              </a:spcAft>
+              <a:buNone/>
+              <a:defRPr b="0" i="0" u="none" kern="1200" baseline="0">
+                <a:solidFill>
+                  <a:schemeClr val="tx1"/>
+                </a:solidFill>
+                <a:latin typeface="Arial" panose="020B0604020202020204" pitchFamily="34" charset="0"/>
+                <a:ea typeface="Arial" panose="020B0604020202020204" pitchFamily="34" charset="0"/>
+                <a:cs typeface="+mn-cs"/>
+              </a:defRPr>
+            </a:lvl2pPr>
+            <a:lvl3pPr marL="914400" lvl="2" indent="0" algn="l" defTabSz="914400" rtl="0" eaLnBrk="1" fontAlgn="base" latinLnBrk="0" hangingPunct="1">
+              <a:lnSpc>
+                <a:spcPct val="100000"/>
+              </a:lnSpc>
+              <a:spcBef>
+                <a:spcPct val="0"/>
+              </a:spcBef>
+              <a:spcAft>
+                <a:spcPct val="0"/>
+              </a:spcAft>
+              <a:buNone/>
+              <a:defRPr b="0" i="0" u="none" kern="1200" baseline="0">
+                <a:solidFill>
+                  <a:schemeClr val="tx1"/>
+                </a:solidFill>
+                <a:latin typeface="Arial" panose="020B0604020202020204" pitchFamily="34" charset="0"/>
+                <a:ea typeface="Arial" panose="020B0604020202020204" pitchFamily="34" charset="0"/>
+                <a:cs typeface="+mn-cs"/>
+              </a:defRPr>
+            </a:lvl3pPr>
+            <a:lvl4pPr marL="1371600" lvl="3" indent="0" algn="l" defTabSz="914400" rtl="0" eaLnBrk="1" fontAlgn="base" latinLnBrk="0" hangingPunct="1">
+              <a:lnSpc>
+                <a:spcPct val="100000"/>
+              </a:lnSpc>
+              <a:spcBef>
+                <a:spcPct val="0"/>
+              </a:spcBef>
+              <a:spcAft>
+                <a:spcPct val="0"/>
+              </a:spcAft>
+              <a:buNone/>
+              <a:defRPr b="0" i="0" u="none" kern="1200" baseline="0">
+                <a:solidFill>
+                  <a:schemeClr val="tx1"/>
+                </a:solidFill>
+                <a:latin typeface="Arial" panose="020B0604020202020204" pitchFamily="34" charset="0"/>
+                <a:ea typeface="Arial" panose="020B0604020202020204" pitchFamily="34" charset="0"/>
+                <a:cs typeface="+mn-cs"/>
+              </a:defRPr>
+            </a:lvl4pPr>
+            <a:lvl5pPr marL="1828800" lvl="4" indent="0" algn="l" defTabSz="914400" rtl="0" eaLnBrk="1" fontAlgn="base" latinLnBrk="0" hangingPunct="1">
+              <a:lnSpc>
+                <a:spcPct val="100000"/>
+              </a:lnSpc>
+              <a:spcBef>
+                <a:spcPct val="0"/>
+              </a:spcBef>
+              <a:spcAft>
+                <a:spcPct val="0"/>
+              </a:spcAft>
+              <a:buNone/>
+              <a:defRPr b="0" i="0" u="none" kern="1200" baseline="0">
+                <a:solidFill>
+                  <a:schemeClr val="tx1"/>
+                </a:solidFill>
+                <a:latin typeface="Arial" panose="020B0604020202020204" pitchFamily="34" charset="0"/>
+                <a:ea typeface="Arial" panose="020B0604020202020204" pitchFamily="34" charset="0"/>
+                <a:cs typeface="+mn-cs"/>
+              </a:defRPr>
+            </a:lvl5pPr>
+          </a:lstStyle>
+          <a:p>
+            <a:pPr lvl="0" algn="r">
+              <a:buNone/>
+            </a:pPr>
+            <a:fld id="{9A0DB2DC-4C9A-4742-B13C-FB6460FD3503}" type="slidenum">
+              <a:rPr lang="en-IN" altLang="x-none" sz="1200" dirty="0">
+                <a:solidFill>
+                  <a:srgbClr val="898989"/>
+                </a:solidFill>
+              </a:rPr>
+            </a:fld>
+            <a:endParaRPr lang="en-IN" altLang="x-none" sz="1200" dirty="0">
+              <a:solidFill>
+                <a:srgbClr val="898989"/>
+              </a:solidFill>
+            </a:endParaRPr>
+          </a:p>
+        </p:txBody>
+      </p:sp>
+      <p:pic>
+        <p:nvPicPr>
+          <p:cNvPr id="10245" name="Picture 6"/>
+          <p:cNvPicPr>
+            <a:picLocks noChangeAspect="1"/>
+          </p:cNvPicPr>
+          <p:nvPr/>
+        </p:nvPicPr>
+        <p:blipFill>
+          <a:blip r:embed="rId1"/>
+          <a:stretch>
+            <a:fillRect/>
+          </a:stretch>
+        </p:blipFill>
+        <p:spPr>
+          <a:xfrm>
+            <a:off x="28575" y="5676900"/>
+            <a:ext cx="12163425" cy="1181100"/>
+          </a:xfrm>
+          <a:prstGeom prst="rect">
+            <a:avLst/>
+          </a:prstGeom>
+          <a:noFill/>
+          <a:ln w="9525">
+            <a:noFill/>
+          </a:ln>
+        </p:spPr>
+      </p:pic>
+      <p:pic>
+        <p:nvPicPr>
+          <p:cNvPr id="10246" name="Picture 2"/>
+          <p:cNvPicPr>
+            <a:picLocks noChangeAspect="1"/>
+          </p:cNvPicPr>
+          <p:nvPr/>
+        </p:nvPicPr>
+        <p:blipFill>
+          <a:blip r:embed="rId2"/>
+          <a:stretch>
+            <a:fillRect/>
+          </a:stretch>
+        </p:blipFill>
+        <p:spPr>
+          <a:xfrm>
+            <a:off x="149225" y="0"/>
+            <a:ext cx="11761788" cy="1301750"/>
+          </a:xfrm>
+          <a:prstGeom prst="rect">
+            <a:avLst/>
+          </a:prstGeom>
+          <a:noFill/>
+          <a:ln w="9525">
+            <a:noFill/>
+          </a:ln>
+        </p:spPr>
+      </p:pic>
+    </p:spTree>
+  </p:cSld>
+  <p:clrMapOvr>
+    <a:masterClrMapping/>
+  </p:clrMapOvr>
+</p:sld>
+</file>
+
+<file path=ppt/slides/slide11.xml><?xml version="1.0" encoding="utf-8"?>
+<p:sld xmlns:a="http://schemas.openxmlformats.org/drawingml/2006/main" xmlns:r="http://schemas.openxmlformats.org/officeDocument/2006/relationships" xmlns:p="http://schemas.openxmlformats.org/presentationml/2006/main">
+  <p:cSld>
+    <p:spTree>
+      <p:nvGrpSpPr>
+        <p:cNvPr id="1" name=""/>
+        <p:cNvGrpSpPr/>
+        <p:nvPr/>
+      </p:nvGrpSpPr>
+      <p:grpSpPr/>
+      <p:sp>
+        <p:nvSpPr>
           <p:cNvPr id="11266" name="Title 1"/>
           <p:cNvSpPr>
             <a:spLocks noGrp="1"/>
@@ -5993,7 +6303,7 @@
 </p:sld>
 </file>
 
-<file path=ppt/slides/slide11.xml><?xml version="1.0" encoding="utf-8"?>
+<file path=ppt/slides/slide12.xml><?xml version="1.0" encoding="utf-8"?>
 <p:sld xmlns:a="http://schemas.openxmlformats.org/drawingml/2006/main" xmlns:r="http://schemas.openxmlformats.org/officeDocument/2006/relationships" xmlns:p="http://schemas.openxmlformats.org/presentationml/2006/main">
   <p:cSld>
     <p:spTree>
@@ -6379,7 +6689,7 @@
 </p:sld>
 </file>
 
-<file path=ppt/slides/slide12.xml><?xml version="1.0" encoding="utf-8"?>
+<file path=ppt/slides/slide13.xml><?xml version="1.0" encoding="utf-8"?>
 <p:sld xmlns:a="http://schemas.openxmlformats.org/drawingml/2006/main" xmlns:r="http://schemas.openxmlformats.org/officeDocument/2006/relationships" xmlns:p="http://schemas.openxmlformats.org/presentationml/2006/main">
   <p:cSld>
     <p:spTree>
@@ -6709,7 +7019,7 @@
 </p:sld>
 </file>
 
-<file path=ppt/slides/slide13.xml><?xml version="1.0" encoding="utf-8"?>
+<file path=ppt/slides/slide14.xml><?xml version="1.0" encoding="utf-8"?>
 <p:sld xmlns:a="http://schemas.openxmlformats.org/drawingml/2006/main" xmlns:r="http://schemas.openxmlformats.org/officeDocument/2006/relationships" xmlns:p="http://schemas.openxmlformats.org/presentationml/2006/main">
   <p:cSld>
     <p:spTree>
@@ -7612,7 +7922,7 @@
 </p:sld>
 </file>
 
-<file path=ppt/slides/slide14.xml><?xml version="1.0" encoding="utf-8"?>
+<file path=ppt/slides/slide15.xml><?xml version="1.0" encoding="utf-8"?>
 <p:sld xmlns:a="http://schemas.openxmlformats.org/drawingml/2006/main" xmlns:r="http://schemas.openxmlformats.org/officeDocument/2006/relationships" xmlns:p="http://schemas.openxmlformats.org/presentationml/2006/main">
   <p:cSld>
     <p:spTree>
@@ -7950,7 +8260,7 @@
 </p:sld>
 </file>
 
-<file path=ppt/slides/slide15.xml><?xml version="1.0" encoding="utf-8"?>
+<file path=ppt/slides/slide16.xml><?xml version="1.0" encoding="utf-8"?>
 <p:sld xmlns:a="http://schemas.openxmlformats.org/drawingml/2006/main" xmlns:r="http://schemas.openxmlformats.org/officeDocument/2006/relationships" xmlns:p="http://schemas.openxmlformats.org/presentationml/2006/main">
   <p:cSld>
     <p:spTree>
@@ -8594,7 +8904,7 @@
 </p:sld>
 </file>
 
-<file path=ppt/slides/slide16.xml><?xml version="1.0" encoding="utf-8"?>
+<file path=ppt/slides/slide17.xml><?xml version="1.0" encoding="utf-8"?>
 <p:sld xmlns:a="http://schemas.openxmlformats.org/drawingml/2006/main" xmlns:r="http://schemas.openxmlformats.org/officeDocument/2006/relationships" xmlns:p="http://schemas.openxmlformats.org/presentationml/2006/main">
   <p:cSld>
     <p:spTree>
@@ -8939,7 +9249,7 @@
 </p:sld>
 </file>
 
-<file path=ppt/slides/slide17.xml><?xml version="1.0" encoding="utf-8"?>
+<file path=ppt/slides/slide18.xml><?xml version="1.0" encoding="utf-8"?>
 <p:sld xmlns:a="http://schemas.openxmlformats.org/drawingml/2006/main" xmlns:r="http://schemas.openxmlformats.org/officeDocument/2006/relationships" xmlns:p="http://schemas.openxmlformats.org/presentationml/2006/main">
   <p:cSld>
     <p:spTree>
@@ -9264,7 +9574,7 @@
 </p:sld>
 </file>
 
-<file path=ppt/slides/slide18.xml><?xml version="1.0" encoding="utf-8"?>
+<file path=ppt/slides/slide19.xml><?xml version="1.0" encoding="utf-8"?>
 <p:sld xmlns:a="http://schemas.openxmlformats.org/drawingml/2006/main" xmlns:r="http://schemas.openxmlformats.org/officeDocument/2006/relationships" xmlns:p="http://schemas.openxmlformats.org/presentationml/2006/main">
   <p:cSld>
     <p:spTree>
@@ -9673,7 +9983,303 @@
 </p:sld>
 </file>
 
-<file path=ppt/slides/slide19.xml><?xml version="1.0" encoding="utf-8"?>
+<file path=ppt/slides/slide2.xml><?xml version="1.0" encoding="utf-8"?>
+<p:sld xmlns:a="http://schemas.openxmlformats.org/drawingml/2006/main" xmlns:r="http://schemas.openxmlformats.org/officeDocument/2006/relationships" xmlns:p="http://schemas.openxmlformats.org/presentationml/2006/main">
+  <p:cSld>
+    <p:spTree>
+      <p:nvGrpSpPr>
+        <p:cNvPr id="1" name=""/>
+        <p:cNvGrpSpPr/>
+        <p:nvPr/>
+      </p:nvGrpSpPr>
+      <p:grpSpPr/>
+      <p:sp>
+        <p:nvSpPr>
+          <p:cNvPr id="4098" name="Title 1"/>
+          <p:cNvSpPr>
+            <a:spLocks noGrp="1"/>
+          </p:cNvSpPr>
+          <p:nvPr>
+            <p:ph type="title"/>
+          </p:nvPr>
+        </p:nvSpPr>
+        <p:spPr>
+          <a:xfrm>
+            <a:off x="838200" y="989013"/>
+            <a:ext cx="10515600" cy="1325562"/>
+          </a:xfrm>
+        </p:spPr>
+        <p:txBody>
+          <a:bodyPr vert="horz" wrap="square" lIns="91440" tIns="45720" rIns="91440" bIns="45720" anchor="ctr" anchorCtr="0"/>
+          <a:p>
+            <a:pPr>
+              <a:buNone/>
+            </a:pPr>
+            <a:r>
+              <a:rPr lang="en-IN" altLang="x-none" dirty="0">
+                <a:latin typeface="Times New Roman" panose="02020603050405020304" pitchFamily="18" charset="0"/>
+                <a:cs typeface="Times New Roman" panose="02020603050405020304" pitchFamily="18" charset="0"/>
+              </a:rPr>
+              <a:t>Abstract</a:t>
+            </a:r>
+            <a:endParaRPr lang="en-IN" altLang="x-none" dirty="0">
+              <a:latin typeface="Times New Roman" panose="02020603050405020304" pitchFamily="18" charset="0"/>
+              <a:ea typeface="Times New Roman" panose="02020603050405020304" pitchFamily="18" charset="0"/>
+            </a:endParaRPr>
+          </a:p>
+        </p:txBody>
+      </p:sp>
+      <p:sp>
+        <p:nvSpPr>
+          <p:cNvPr id="4099" name="Content Placeholder 2"/>
+          <p:cNvSpPr>
+            <a:spLocks noGrp="1"/>
+          </p:cNvSpPr>
+          <p:nvPr>
+            <p:ph idx="1"/>
+          </p:nvPr>
+        </p:nvSpPr>
+        <p:spPr>
+          <a:xfrm>
+            <a:off x="838200" y="2006600"/>
+            <a:ext cx="10515600" cy="4273550"/>
+          </a:xfrm>
+        </p:spPr>
+        <p:txBody>
+          <a:bodyPr vert="horz" wrap="square" lIns="91440" tIns="45720" rIns="91440" bIns="45720" anchor="t" anchorCtr="0"/>
+          <a:p>
+            <a:pPr algn="just"/>
+            <a:r>
+              <a:rPr lang="en-US" altLang="en-US" sz="1800" dirty="0"/>
+              <a:t>Gold is a reliable investment asset, but forecasting its price is challenging due to market volatility and complex time-series patterns.</a:t>
+            </a:r>
+            <a:endParaRPr lang="en-US" altLang="en-US" sz="1800" dirty="0"/>
+          </a:p>
+          <a:p>
+            <a:pPr algn="just"/>
+            <a:r>
+              <a:rPr lang="en-US" altLang="en-US" sz="1800" dirty="0"/>
+              <a:t>This project proposes an advanced gold price forecasting system using an ensemble of Chronos-T5 and N-HiTS models to improve prediction accuracy and stability across multiple horizons, including next-day, next-week, and next-month forecasts.</a:t>
+            </a:r>
+            <a:endParaRPr lang="en-US" altLang="en-US" sz="1800" dirty="0"/>
+          </a:p>
+          <a:p>
+            <a:pPr algn="just"/>
+            <a:r>
+              <a:rPr lang="en-US" altLang="en-US" sz="1800" dirty="0"/>
+              <a:t>The system integrates data ingestion, preprocessing, feature engineering, model evaluation, and visualization into a complete end-to-end pipeline.</a:t>
+            </a:r>
+            <a:endParaRPr lang="en-US" altLang="en-US" sz="1800" dirty="0"/>
+          </a:p>
+          <a:p>
+            <a:pPr algn="just"/>
+            <a:r>
+              <a:rPr lang="en-US" altLang="en-US" sz="1800" dirty="0"/>
+              <a:t>SQLite is used for cost-effective local storage, and a Streamlit dashboard provides interactive forecasting and analysis for investors.</a:t>
+            </a:r>
+            <a:endParaRPr lang="en-US" altLang="en-US" sz="1800" dirty="0"/>
+          </a:p>
+        </p:txBody>
+      </p:sp>
+      <p:sp>
+        <p:nvSpPr>
+          <p:cNvPr id="4" name="Slide Number Placeholder 3"/>
+          <p:cNvSpPr txBox="1">
+            <a:spLocks noGrp="1"/>
+          </p:cNvSpPr>
+          <p:nvPr>
+            <p:ph type="sldNum" sz="quarter" idx="12"/>
+          </p:nvPr>
+        </p:nvSpPr>
+        <p:spPr>
+          <a:noFill/>
+        </p:spPr>
+        <p:txBody>
+          <a:bodyPr vert="horz" lIns="91440" tIns="45720" rIns="91440" bIns="45720" rtlCol="0" anchor="ctr"/>
+          <a:lstStyle>
+            <a:lvl1pPr marL="0" lvl="0" indent="0" algn="l" defTabSz="914400" rtl="0" eaLnBrk="1" fontAlgn="base" latinLnBrk="0" hangingPunct="1">
+              <a:lnSpc>
+                <a:spcPct val="100000"/>
+              </a:lnSpc>
+              <a:spcBef>
+                <a:spcPct val="0"/>
+              </a:spcBef>
+              <a:spcAft>
+                <a:spcPct val="0"/>
+              </a:spcAft>
+              <a:buNone/>
+              <a:defRPr sz="1800" b="0" i="0" u="none" kern="1200" baseline="0">
+                <a:solidFill>
+                  <a:schemeClr val="tx1"/>
+                </a:solidFill>
+                <a:latin typeface="Calibri" panose="020F0502020204030204" pitchFamily="34" charset="0"/>
+              </a:defRPr>
+            </a:lvl1pPr>
+            <a:lvl2pPr marL="457200" lvl="1" indent="0" algn="l" defTabSz="914400" rtl="0" eaLnBrk="1" fontAlgn="base" latinLnBrk="0" hangingPunct="1">
+              <a:lnSpc>
+                <a:spcPct val="100000"/>
+              </a:lnSpc>
+              <a:spcBef>
+                <a:spcPct val="0"/>
+              </a:spcBef>
+              <a:spcAft>
+                <a:spcPct val="0"/>
+              </a:spcAft>
+              <a:buNone/>
+              <a:defRPr b="0" i="0" u="none" kern="1200" baseline="0">
+                <a:solidFill>
+                  <a:schemeClr val="tx1"/>
+                </a:solidFill>
+                <a:latin typeface="Arial" panose="020B0604020202020204" pitchFamily="34" charset="0"/>
+                <a:ea typeface="Arial" panose="020B0604020202020204" pitchFamily="34" charset="0"/>
+                <a:cs typeface="+mn-cs"/>
+              </a:defRPr>
+            </a:lvl2pPr>
+            <a:lvl3pPr marL="914400" lvl="2" indent="0" algn="l" defTabSz="914400" rtl="0" eaLnBrk="1" fontAlgn="base" latinLnBrk="0" hangingPunct="1">
+              <a:lnSpc>
+                <a:spcPct val="100000"/>
+              </a:lnSpc>
+              <a:spcBef>
+                <a:spcPct val="0"/>
+              </a:spcBef>
+              <a:spcAft>
+                <a:spcPct val="0"/>
+              </a:spcAft>
+              <a:buNone/>
+              <a:defRPr b="0" i="0" u="none" kern="1200" baseline="0">
+                <a:solidFill>
+                  <a:schemeClr val="tx1"/>
+                </a:solidFill>
+                <a:latin typeface="Arial" panose="020B0604020202020204" pitchFamily="34" charset="0"/>
+                <a:ea typeface="Arial" panose="020B0604020202020204" pitchFamily="34" charset="0"/>
+                <a:cs typeface="+mn-cs"/>
+              </a:defRPr>
+            </a:lvl3pPr>
+            <a:lvl4pPr marL="1371600" lvl="3" indent="0" algn="l" defTabSz="914400" rtl="0" eaLnBrk="1" fontAlgn="base" latinLnBrk="0" hangingPunct="1">
+              <a:lnSpc>
+                <a:spcPct val="100000"/>
+              </a:lnSpc>
+              <a:spcBef>
+                <a:spcPct val="0"/>
+              </a:spcBef>
+              <a:spcAft>
+                <a:spcPct val="0"/>
+              </a:spcAft>
+              <a:buNone/>
+              <a:defRPr b="0" i="0" u="none" kern="1200" baseline="0">
+                <a:solidFill>
+                  <a:schemeClr val="tx1"/>
+                </a:solidFill>
+                <a:latin typeface="Arial" panose="020B0604020202020204" pitchFamily="34" charset="0"/>
+                <a:ea typeface="Arial" panose="020B0604020202020204" pitchFamily="34" charset="0"/>
+                <a:cs typeface="+mn-cs"/>
+              </a:defRPr>
+            </a:lvl4pPr>
+            <a:lvl5pPr marL="1828800" lvl="4" indent="0" algn="l" defTabSz="914400" rtl="0" eaLnBrk="1" fontAlgn="base" latinLnBrk="0" hangingPunct="1">
+              <a:lnSpc>
+                <a:spcPct val="100000"/>
+              </a:lnSpc>
+              <a:spcBef>
+                <a:spcPct val="0"/>
+              </a:spcBef>
+              <a:spcAft>
+                <a:spcPct val="0"/>
+              </a:spcAft>
+              <a:buNone/>
+              <a:defRPr b="0" i="0" u="none" kern="1200" baseline="0">
+                <a:solidFill>
+                  <a:schemeClr val="tx1"/>
+                </a:solidFill>
+                <a:latin typeface="Arial" panose="020B0604020202020204" pitchFamily="34" charset="0"/>
+                <a:ea typeface="Arial" panose="020B0604020202020204" pitchFamily="34" charset="0"/>
+                <a:cs typeface="+mn-cs"/>
+              </a:defRPr>
+            </a:lvl5pPr>
+          </a:lstStyle>
+          <a:p>
+            <a:pPr lvl="0" algn="r">
+              <a:buNone/>
+            </a:pPr>
+            <a:fld id="{9A0DB2DC-4C9A-4742-B13C-FB6460FD3503}" type="slidenum">
+              <a:rPr lang="en-IN" altLang="x-none" sz="1200" dirty="0">
+                <a:solidFill>
+                  <a:srgbClr val="898989"/>
+                </a:solidFill>
+              </a:rPr>
+            </a:fld>
+            <a:endParaRPr lang="en-IN" altLang="x-none" sz="1200" dirty="0">
+              <a:solidFill>
+                <a:srgbClr val="898989"/>
+              </a:solidFill>
+            </a:endParaRPr>
+          </a:p>
+        </p:txBody>
+      </p:sp>
+      <p:pic>
+        <p:nvPicPr>
+          <p:cNvPr id="4101" name="Picture 2"/>
+          <p:cNvPicPr>
+            <a:picLocks noChangeAspect="1"/>
+          </p:cNvPicPr>
+          <p:nvPr/>
+        </p:nvPicPr>
+        <p:blipFill>
+          <a:blip r:embed="rId1"/>
+          <a:stretch>
+            <a:fillRect/>
+          </a:stretch>
+        </p:blipFill>
+        <p:spPr>
+          <a:xfrm>
+            <a:off x="201613" y="0"/>
+            <a:ext cx="11761787" cy="1301750"/>
+          </a:xfrm>
+          <a:prstGeom prst="rect">
+            <a:avLst/>
+          </a:prstGeom>
+          <a:noFill/>
+          <a:ln w="9525">
+            <a:noFill/>
+          </a:ln>
+        </p:spPr>
+      </p:pic>
+      <p:pic>
+        <p:nvPicPr>
+          <p:cNvPr id="13317" name="Picture 6"/>
+          <p:cNvPicPr>
+            <a:picLocks noChangeAspect="1"/>
+          </p:cNvPicPr>
+          <p:nvPr/>
+        </p:nvPicPr>
+        <p:blipFill>
+          <a:blip r:embed="rId2"/>
+          <a:stretch>
+            <a:fillRect/>
+          </a:stretch>
+        </p:blipFill>
+        <p:spPr>
+          <a:xfrm>
+            <a:off x="0" y="5676900"/>
+            <a:ext cx="12192000" cy="1181100"/>
+          </a:xfrm>
+          <a:prstGeom prst="rect">
+            <a:avLst/>
+          </a:prstGeom>
+          <a:noFill/>
+          <a:ln w="9525">
+            <a:noFill/>
+          </a:ln>
+        </p:spPr>
+      </p:pic>
+    </p:spTree>
+  </p:cSld>
+  <p:clrMapOvr>
+    <a:masterClrMapping/>
+  </p:clrMapOvr>
+</p:sld>
+</file>
+
+<file path=ppt/slides/slide20.xml><?xml version="1.0" encoding="utf-8"?>
 <p:sld xmlns:a="http://schemas.openxmlformats.org/drawingml/2006/main" xmlns:r="http://schemas.openxmlformats.org/officeDocument/2006/relationships" xmlns:p="http://schemas.openxmlformats.org/presentationml/2006/main">
   <p:cSld>
     <p:spTree>
@@ -10083,319 +10689,7 @@
 </p:sld>
 </file>
 
-<file path=ppt/slides/slide2.xml><?xml version="1.0" encoding="utf-8"?>
-<p:sld xmlns:a="http://schemas.openxmlformats.org/drawingml/2006/main" xmlns:r="http://schemas.openxmlformats.org/officeDocument/2006/relationships" xmlns:p="http://schemas.openxmlformats.org/presentationml/2006/main">
-  <p:cSld>
-    <p:spTree>
-      <p:nvGrpSpPr>
-        <p:cNvPr id="1" name=""/>
-        <p:cNvGrpSpPr/>
-        <p:nvPr/>
-      </p:nvGrpSpPr>
-      <p:grpSpPr/>
-      <p:sp>
-        <p:nvSpPr>
-          <p:cNvPr id="3074" name="Title 1"/>
-          <p:cNvSpPr>
-            <a:spLocks noGrp="1"/>
-          </p:cNvSpPr>
-          <p:nvPr>
-            <p:ph type="title"/>
-          </p:nvPr>
-        </p:nvSpPr>
-        <p:spPr>
-          <a:xfrm>
-            <a:off x="855663" y="936625"/>
-            <a:ext cx="10515600" cy="1325563"/>
-          </a:xfrm>
-        </p:spPr>
-        <p:txBody>
-          <a:bodyPr vert="horz" wrap="square" lIns="91440" tIns="45720" rIns="91440" bIns="45720" anchor="ctr" anchorCtr="0"/>
-          <a:p>
-            <a:pPr>
-              <a:buNone/>
-            </a:pPr>
-            <a:br>
-              <a:rPr lang="en-IN" altLang="x-none" dirty="0">
-                <a:latin typeface="Times New Roman" panose="02020603050405020304" pitchFamily="18" charset="0"/>
-                <a:cs typeface="Times New Roman" panose="02020603050405020304" pitchFamily="18" charset="0"/>
-              </a:rPr>
-            </a:br>
-            <a:r>
-              <a:rPr lang="en-IN" altLang="x-none" dirty="0">
-                <a:latin typeface="Times New Roman" panose="02020603050405020304" pitchFamily="18" charset="0"/>
-                <a:cs typeface="Times New Roman" panose="02020603050405020304" pitchFamily="18" charset="0"/>
-              </a:rPr>
-              <a:t>Objective</a:t>
-            </a:r>
-            <a:endParaRPr lang="en-IN" altLang="x-none" dirty="0">
-              <a:latin typeface="Times New Roman" panose="02020603050405020304" pitchFamily="18" charset="0"/>
-              <a:ea typeface="Times New Roman" panose="02020603050405020304" pitchFamily="18" charset="0"/>
-            </a:endParaRPr>
-          </a:p>
-        </p:txBody>
-      </p:sp>
-      <p:sp>
-        <p:nvSpPr>
-          <p:cNvPr id="3075" name="Content Placeholder 2"/>
-          <p:cNvSpPr>
-            <a:spLocks noGrp="1"/>
-          </p:cNvSpPr>
-          <p:nvPr>
-            <p:ph idx="1"/>
-          </p:nvPr>
-        </p:nvSpPr>
-        <p:spPr>
-          <a:xfrm>
-            <a:off x="838200" y="2416175"/>
-            <a:ext cx="10515600" cy="4176713"/>
-          </a:xfrm>
-        </p:spPr>
-        <p:txBody>
-          <a:bodyPr vert="horz" wrap="square" lIns="91440" tIns="45720" rIns="91440" bIns="45720" anchor="t" anchorCtr="0"/>
-          <a:p>
-            <a:pPr marL="0" indent="0" algn="just"/>
-            <a:r>
-              <a:rPr lang="en-US" altLang="en-US" sz="2000" b="1" dirty="0">
-                <a:latin typeface="Times New Roman" panose="02020603050405020304" pitchFamily="18" charset="0"/>
-                <a:ea typeface="Times New Roman" panose="02020603050405020304" pitchFamily="18" charset="0"/>
-              </a:rPr>
-              <a:t>The objective of this project is to develop an investor-focused gold price forecasting system capable of predicting gold prices across multiple future horizons such as next day, next week, and next month with improved accuracy and stability.</a:t>
-            </a:r>
-            <a:endParaRPr lang="en-US" altLang="en-US" sz="2000" b="1" dirty="0">
-              <a:latin typeface="Times New Roman" panose="02020603050405020304" pitchFamily="18" charset="0"/>
-              <a:ea typeface="Times New Roman" panose="02020603050405020304" pitchFamily="18" charset="0"/>
-            </a:endParaRPr>
-          </a:p>
-          <a:p>
-            <a:pPr marL="0" indent="0" algn="just"/>
-            <a:r>
-              <a:rPr lang="en-US" altLang="en-US" sz="2000" b="1" dirty="0">
-                <a:latin typeface="Times New Roman" panose="02020603050405020304" pitchFamily="18" charset="0"/>
-                <a:ea typeface="Times New Roman" panose="02020603050405020304" pitchFamily="18" charset="0"/>
-              </a:rPr>
-              <a:t>The project uses advanced time-series forecasting models, namely Chronos-T5 and N-HiTS, combined through an ensemble approach to overcome the limitations of traditional machine learning models.</a:t>
-            </a:r>
-            <a:endParaRPr lang="en-US" altLang="en-US" sz="2000" b="1" dirty="0">
-              <a:latin typeface="Times New Roman" panose="02020603050405020304" pitchFamily="18" charset="0"/>
-              <a:ea typeface="Times New Roman" panose="02020603050405020304" pitchFamily="18" charset="0"/>
-            </a:endParaRPr>
-          </a:p>
-          <a:p>
-            <a:pPr marL="0" indent="0" algn="just"/>
-            <a:r>
-              <a:rPr lang="en-US" altLang="en-US" sz="2000" b="1" dirty="0">
-                <a:latin typeface="Times New Roman" panose="02020603050405020304" pitchFamily="18" charset="0"/>
-                <a:ea typeface="Times New Roman" panose="02020603050405020304" pitchFamily="18" charset="0"/>
-              </a:rPr>
-              <a:t>It also aims to provide an interactive and production-ready dashboard for visualization, analysis, and decision-making using automated data pipelines and real-time forecasting techniques.</a:t>
-            </a:r>
-            <a:endParaRPr lang="en-US" altLang="en-US" sz="2000" b="1" dirty="0">
-              <a:latin typeface="Times New Roman" panose="02020603050405020304" pitchFamily="18" charset="0"/>
-              <a:ea typeface="Times New Roman" panose="02020603050405020304" pitchFamily="18" charset="0"/>
-            </a:endParaRPr>
-          </a:p>
-        </p:txBody>
-      </p:sp>
-      <p:sp>
-        <p:nvSpPr>
-          <p:cNvPr id="4" name="Slide Number Placeholder 3"/>
-          <p:cNvSpPr txBox="1">
-            <a:spLocks noGrp="1"/>
-          </p:cNvSpPr>
-          <p:nvPr>
-            <p:ph type="sldNum" sz="quarter" idx="12"/>
-          </p:nvPr>
-        </p:nvSpPr>
-        <p:spPr>
-          <a:noFill/>
-        </p:spPr>
-        <p:txBody>
-          <a:bodyPr vert="horz" lIns="91440" tIns="45720" rIns="91440" bIns="45720" rtlCol="0" anchor="ctr"/>
-          <a:lstStyle>
-            <a:lvl1pPr marL="0" lvl="0" indent="0" algn="l" defTabSz="914400" rtl="0" eaLnBrk="1" fontAlgn="base" latinLnBrk="0" hangingPunct="1">
-              <a:lnSpc>
-                <a:spcPct val="100000"/>
-              </a:lnSpc>
-              <a:spcBef>
-                <a:spcPct val="0"/>
-              </a:spcBef>
-              <a:spcAft>
-                <a:spcPct val="0"/>
-              </a:spcAft>
-              <a:buNone/>
-              <a:defRPr sz="1800" b="0" i="0" u="none" kern="1200" baseline="0">
-                <a:solidFill>
-                  <a:schemeClr val="tx1"/>
-                </a:solidFill>
-                <a:latin typeface="Calibri" panose="020F0502020204030204" pitchFamily="34" charset="0"/>
-              </a:defRPr>
-            </a:lvl1pPr>
-            <a:lvl2pPr marL="457200" lvl="1" indent="0" algn="l" defTabSz="914400" rtl="0" eaLnBrk="1" fontAlgn="base" latinLnBrk="0" hangingPunct="1">
-              <a:lnSpc>
-                <a:spcPct val="100000"/>
-              </a:lnSpc>
-              <a:spcBef>
-                <a:spcPct val="0"/>
-              </a:spcBef>
-              <a:spcAft>
-                <a:spcPct val="0"/>
-              </a:spcAft>
-              <a:buNone/>
-              <a:defRPr b="0" i="0" u="none" kern="1200" baseline="0">
-                <a:solidFill>
-                  <a:schemeClr val="tx1"/>
-                </a:solidFill>
-                <a:latin typeface="Arial" panose="020B0604020202020204" pitchFamily="34" charset="0"/>
-                <a:ea typeface="Arial" panose="020B0604020202020204" pitchFamily="34" charset="0"/>
-                <a:cs typeface="+mn-cs"/>
-              </a:defRPr>
-            </a:lvl2pPr>
-            <a:lvl3pPr marL="914400" lvl="2" indent="0" algn="l" defTabSz="914400" rtl="0" eaLnBrk="1" fontAlgn="base" latinLnBrk="0" hangingPunct="1">
-              <a:lnSpc>
-                <a:spcPct val="100000"/>
-              </a:lnSpc>
-              <a:spcBef>
-                <a:spcPct val="0"/>
-              </a:spcBef>
-              <a:spcAft>
-                <a:spcPct val="0"/>
-              </a:spcAft>
-              <a:buNone/>
-              <a:defRPr b="0" i="0" u="none" kern="1200" baseline="0">
-                <a:solidFill>
-                  <a:schemeClr val="tx1"/>
-                </a:solidFill>
-                <a:latin typeface="Arial" panose="020B0604020202020204" pitchFamily="34" charset="0"/>
-                <a:ea typeface="Arial" panose="020B0604020202020204" pitchFamily="34" charset="0"/>
-                <a:cs typeface="+mn-cs"/>
-              </a:defRPr>
-            </a:lvl3pPr>
-            <a:lvl4pPr marL="1371600" lvl="3" indent="0" algn="l" defTabSz="914400" rtl="0" eaLnBrk="1" fontAlgn="base" latinLnBrk="0" hangingPunct="1">
-              <a:lnSpc>
-                <a:spcPct val="100000"/>
-              </a:lnSpc>
-              <a:spcBef>
-                <a:spcPct val="0"/>
-              </a:spcBef>
-              <a:spcAft>
-                <a:spcPct val="0"/>
-              </a:spcAft>
-              <a:buNone/>
-              <a:defRPr b="0" i="0" u="none" kern="1200" baseline="0">
-                <a:solidFill>
-                  <a:schemeClr val="tx1"/>
-                </a:solidFill>
-                <a:latin typeface="Arial" panose="020B0604020202020204" pitchFamily="34" charset="0"/>
-                <a:ea typeface="Arial" panose="020B0604020202020204" pitchFamily="34" charset="0"/>
-                <a:cs typeface="+mn-cs"/>
-              </a:defRPr>
-            </a:lvl4pPr>
-            <a:lvl5pPr marL="1828800" lvl="4" indent="0" algn="l" defTabSz="914400" rtl="0" eaLnBrk="1" fontAlgn="base" latinLnBrk="0" hangingPunct="1">
-              <a:lnSpc>
-                <a:spcPct val="100000"/>
-              </a:lnSpc>
-              <a:spcBef>
-                <a:spcPct val="0"/>
-              </a:spcBef>
-              <a:spcAft>
-                <a:spcPct val="0"/>
-              </a:spcAft>
-              <a:buNone/>
-              <a:defRPr b="0" i="0" u="none" kern="1200" baseline="0">
-                <a:solidFill>
-                  <a:schemeClr val="tx1"/>
-                </a:solidFill>
-                <a:latin typeface="Arial" panose="020B0604020202020204" pitchFamily="34" charset="0"/>
-                <a:ea typeface="Arial" panose="020B0604020202020204" pitchFamily="34" charset="0"/>
-                <a:cs typeface="+mn-cs"/>
-              </a:defRPr>
-            </a:lvl5pPr>
-          </a:lstStyle>
-          <a:p>
-            <a:pPr lvl="0" algn="r">
-              <a:buNone/>
-            </a:pPr>
-            <a:fld id="{9A0DB2DC-4C9A-4742-B13C-FB6460FD3503}" type="slidenum">
-              <a:rPr lang="en-IN" altLang="x-none" sz="1200" dirty="0">
-                <a:solidFill>
-                  <a:srgbClr val="898989"/>
-                </a:solidFill>
-              </a:rPr>
-            </a:fld>
-            <a:endParaRPr lang="en-IN" altLang="x-none" sz="1200" dirty="0">
-              <a:solidFill>
-                <a:srgbClr val="898989"/>
-              </a:solidFill>
-            </a:endParaRPr>
-          </a:p>
-        </p:txBody>
-      </p:sp>
-      <p:pic>
-        <p:nvPicPr>
-          <p:cNvPr id="3077" name="Picture 7"/>
-          <p:cNvPicPr>
-            <a:picLocks noChangeAspect="1"/>
-          </p:cNvPicPr>
-          <p:nvPr/>
-        </p:nvPicPr>
-        <p:blipFill>
-          <a:blip r:embed="rId1"/>
-          <a:stretch>
-            <a:fillRect/>
-          </a:stretch>
-        </p:blipFill>
-        <p:spPr>
-          <a:xfrm>
-            <a:off x="0" y="5676900"/>
-            <a:ext cx="12192635" cy="1181100"/>
-          </a:xfrm>
-          <a:prstGeom prst="rect">
-            <a:avLst/>
-          </a:prstGeom>
-          <a:noFill/>
-          <a:ln w="9525">
-            <a:noFill/>
-          </a:ln>
-        </p:spPr>
-      </p:pic>
-      <p:pic>
-        <p:nvPicPr>
-          <p:cNvPr id="3078" name="Picture 2"/>
-          <p:cNvPicPr>
-            <a:picLocks noChangeAspect="1"/>
-          </p:cNvPicPr>
-          <p:nvPr/>
-        </p:nvPicPr>
-        <p:blipFill>
-          <a:blip r:embed="rId2"/>
-          <a:stretch>
-            <a:fillRect/>
-          </a:stretch>
-        </p:blipFill>
-        <p:spPr>
-          <a:xfrm>
-            <a:off x="298450" y="0"/>
-            <a:ext cx="11761788" cy="1301750"/>
-          </a:xfrm>
-          <a:prstGeom prst="rect">
-            <a:avLst/>
-          </a:prstGeom>
-          <a:noFill/>
-          <a:ln w="9525">
-            <a:noFill/>
-          </a:ln>
-        </p:spPr>
-      </p:pic>
-    </p:spTree>
-  </p:cSld>
-  <p:clrMapOvr>
-    <a:masterClrMapping/>
-  </p:clrMapOvr>
-</p:sld>
-</file>
-
-<file path=ppt/slides/slide20.xml><?xml version="1.0" encoding="utf-8"?>
+<file path=ppt/slides/slide21.xml><?xml version="1.0" encoding="utf-8"?>
 <p:sld xmlns:a="http://schemas.openxmlformats.org/drawingml/2006/main" xmlns:r="http://schemas.openxmlformats.org/officeDocument/2006/relationships" xmlns:p="http://schemas.openxmlformats.org/presentationml/2006/main">
   <p:cSld>
     <p:spTree>
@@ -10855,7 +11149,7 @@
 </p:sld>
 </file>
 
-<file path=ppt/slides/slide21.xml><?xml version="1.0" encoding="utf-8"?>
+<file path=ppt/slides/slide22.xml><?xml version="1.0" encoding="utf-8"?>
 <p:sld xmlns:a="http://schemas.openxmlformats.org/drawingml/2006/main" xmlns:r="http://schemas.openxmlformats.org/officeDocument/2006/relationships" xmlns:p="http://schemas.openxmlformats.org/presentationml/2006/main">
   <p:cSld>
     <p:spTree>
@@ -11594,7 +11888,7 @@
 </p:sld>
 </file>
 
-<file path=ppt/slides/slide22.xml><?xml version="1.0" encoding="utf-8"?>
+<file path=ppt/slides/slide23.xml><?xml version="1.0" encoding="utf-8"?>
 <p:sld xmlns:a="http://schemas.openxmlformats.org/drawingml/2006/main" xmlns:r="http://schemas.openxmlformats.org/officeDocument/2006/relationships" xmlns:p="http://schemas.openxmlformats.org/presentationml/2006/main">
   <p:cSld>
     <p:spTree>
@@ -12350,7 +12644,7 @@
 </p:sld>
 </file>
 
-<file path=ppt/slides/slide23.xml><?xml version="1.0" encoding="utf-8"?>
+<file path=ppt/slides/slide24.xml><?xml version="1.0" encoding="utf-8"?>
 <p:sld xmlns:a="http://schemas.openxmlformats.org/drawingml/2006/main" xmlns:r="http://schemas.openxmlformats.org/officeDocument/2006/relationships" xmlns:p="http://schemas.openxmlformats.org/presentationml/2006/main">
   <p:cSld>
     <p:spTree>
@@ -12624,7 +12918,7 @@
 </p:sld>
 </file>
 
-<file path=ppt/slides/slide24.xml><?xml version="1.0" encoding="utf-8"?>
+<file path=ppt/slides/slide25.xml><?xml version="1.0" encoding="utf-8"?>
 <p:sld xmlns:a="http://schemas.openxmlformats.org/drawingml/2006/main" xmlns:r="http://schemas.openxmlformats.org/officeDocument/2006/relationships" xmlns:p="http://schemas.openxmlformats.org/presentationml/2006/main">
   <p:cSld>
     <p:spTree>
@@ -12898,7 +13192,7 @@
 </p:sld>
 </file>
 
-<file path=ppt/slides/slide25.xml><?xml version="1.0" encoding="utf-8"?>
+<file path=ppt/slides/slide26.xml><?xml version="1.0" encoding="utf-8"?>
 <p:sld xmlns:a="http://schemas.openxmlformats.org/drawingml/2006/main" xmlns:r="http://schemas.openxmlformats.org/officeDocument/2006/relationships" xmlns:p="http://schemas.openxmlformats.org/presentationml/2006/main">
   <p:cSld>
     <p:spTree>
@@ -13172,7 +13466,7 @@
 </p:sld>
 </file>
 
-<file path=ppt/slides/slide26.xml><?xml version="1.0" encoding="utf-8"?>
+<file path=ppt/slides/slide27.xml><?xml version="1.0" encoding="utf-8"?>
 <p:sld xmlns:a="http://schemas.openxmlformats.org/drawingml/2006/main" xmlns:r="http://schemas.openxmlformats.org/officeDocument/2006/relationships" xmlns:p="http://schemas.openxmlformats.org/presentationml/2006/main">
   <p:cSld>
     <p:spTree>
@@ -13541,7 +13835,7 @@
 </p:sld>
 </file>
 
-<file path=ppt/slides/slide27.xml><?xml version="1.0" encoding="utf-8"?>
+<file path=ppt/slides/slide28.xml><?xml version="1.0" encoding="utf-8"?>
 <p:sld xmlns:a="http://schemas.openxmlformats.org/drawingml/2006/main" xmlns:r="http://schemas.openxmlformats.org/officeDocument/2006/relationships" xmlns:p="http://schemas.openxmlformats.org/presentationml/2006/main">
   <p:cSld>
     <p:spTree>
@@ -13840,7 +14134,7 @@
 </p:sld>
 </file>
 
-<file path=ppt/slides/slide28.xml><?xml version="1.0" encoding="utf-8"?>
+<file path=ppt/slides/slide29.xml><?xml version="1.0" encoding="utf-8"?>
 <p:sld xmlns:a="http://schemas.openxmlformats.org/drawingml/2006/main" xmlns:r="http://schemas.openxmlformats.org/officeDocument/2006/relationships" xmlns:p="http://schemas.openxmlformats.org/presentationml/2006/main">
   <p:cSld>
     <p:spTree>
@@ -15395,7 +15689,319 @@
 </p:sld>
 </file>
 
-<file path=ppt/slides/slide29.xml><?xml version="1.0" encoding="utf-8"?>
+<file path=ppt/slides/slide3.xml><?xml version="1.0" encoding="utf-8"?>
+<p:sld xmlns:a="http://schemas.openxmlformats.org/drawingml/2006/main" xmlns:r="http://schemas.openxmlformats.org/officeDocument/2006/relationships" xmlns:p="http://schemas.openxmlformats.org/presentationml/2006/main">
+  <p:cSld>
+    <p:spTree>
+      <p:nvGrpSpPr>
+        <p:cNvPr id="1" name=""/>
+        <p:cNvGrpSpPr/>
+        <p:nvPr/>
+      </p:nvGrpSpPr>
+      <p:grpSpPr/>
+      <p:sp>
+        <p:nvSpPr>
+          <p:cNvPr id="3074" name="Title 1"/>
+          <p:cNvSpPr>
+            <a:spLocks noGrp="1"/>
+          </p:cNvSpPr>
+          <p:nvPr>
+            <p:ph type="title"/>
+          </p:nvPr>
+        </p:nvSpPr>
+        <p:spPr>
+          <a:xfrm>
+            <a:off x="855663" y="936625"/>
+            <a:ext cx="10515600" cy="1325563"/>
+          </a:xfrm>
+        </p:spPr>
+        <p:txBody>
+          <a:bodyPr vert="horz" wrap="square" lIns="91440" tIns="45720" rIns="91440" bIns="45720" anchor="ctr" anchorCtr="0"/>
+          <a:p>
+            <a:pPr>
+              <a:buNone/>
+            </a:pPr>
+            <a:br>
+              <a:rPr lang="en-IN" altLang="x-none" dirty="0">
+                <a:latin typeface="Times New Roman" panose="02020603050405020304" pitchFamily="18" charset="0"/>
+                <a:cs typeface="Times New Roman" panose="02020603050405020304" pitchFamily="18" charset="0"/>
+              </a:rPr>
+            </a:br>
+            <a:r>
+              <a:rPr lang="en-IN" altLang="x-none" dirty="0">
+                <a:latin typeface="Times New Roman" panose="02020603050405020304" pitchFamily="18" charset="0"/>
+                <a:cs typeface="Times New Roman" panose="02020603050405020304" pitchFamily="18" charset="0"/>
+              </a:rPr>
+              <a:t>Objective</a:t>
+            </a:r>
+            <a:endParaRPr lang="en-IN" altLang="x-none" dirty="0">
+              <a:latin typeface="Times New Roman" panose="02020603050405020304" pitchFamily="18" charset="0"/>
+              <a:ea typeface="Times New Roman" panose="02020603050405020304" pitchFamily="18" charset="0"/>
+            </a:endParaRPr>
+          </a:p>
+        </p:txBody>
+      </p:sp>
+      <p:sp>
+        <p:nvSpPr>
+          <p:cNvPr id="3075" name="Content Placeholder 2"/>
+          <p:cNvSpPr>
+            <a:spLocks noGrp="1"/>
+          </p:cNvSpPr>
+          <p:nvPr>
+            <p:ph idx="1"/>
+          </p:nvPr>
+        </p:nvSpPr>
+        <p:spPr>
+          <a:xfrm>
+            <a:off x="838200" y="2416175"/>
+            <a:ext cx="10515600" cy="4176713"/>
+          </a:xfrm>
+        </p:spPr>
+        <p:txBody>
+          <a:bodyPr vert="horz" wrap="square" lIns="91440" tIns="45720" rIns="91440" bIns="45720" anchor="t" anchorCtr="0"/>
+          <a:p>
+            <a:pPr marL="0" indent="0" algn="just"/>
+            <a:r>
+              <a:rPr lang="en-US" altLang="en-US" sz="2000" b="1" dirty="0">
+                <a:latin typeface="Times New Roman" panose="02020603050405020304" pitchFamily="18" charset="0"/>
+                <a:ea typeface="Times New Roman" panose="02020603050405020304" pitchFamily="18" charset="0"/>
+              </a:rPr>
+              <a:t>The objective of this project is to develop an investor-focused gold price forecasting system capable of predicting gold prices across multiple future horizons such as next day, next week, and next month with improved accuracy and stability.</a:t>
+            </a:r>
+            <a:endParaRPr lang="en-US" altLang="en-US" sz="2000" b="1" dirty="0">
+              <a:latin typeface="Times New Roman" panose="02020603050405020304" pitchFamily="18" charset="0"/>
+              <a:ea typeface="Times New Roman" panose="02020603050405020304" pitchFamily="18" charset="0"/>
+            </a:endParaRPr>
+          </a:p>
+          <a:p>
+            <a:pPr marL="0" indent="0" algn="just"/>
+            <a:r>
+              <a:rPr lang="en-US" altLang="en-US" sz="2000" b="1" dirty="0">
+                <a:latin typeface="Times New Roman" panose="02020603050405020304" pitchFamily="18" charset="0"/>
+                <a:ea typeface="Times New Roman" panose="02020603050405020304" pitchFamily="18" charset="0"/>
+              </a:rPr>
+              <a:t>The project uses advanced time-series forecasting models, namely Chronos-T5 and N-HiTS, combined through an ensemble approach to overcome the limitations of traditional machine learning models.</a:t>
+            </a:r>
+            <a:endParaRPr lang="en-US" altLang="en-US" sz="2000" b="1" dirty="0">
+              <a:latin typeface="Times New Roman" panose="02020603050405020304" pitchFamily="18" charset="0"/>
+              <a:ea typeface="Times New Roman" panose="02020603050405020304" pitchFamily="18" charset="0"/>
+            </a:endParaRPr>
+          </a:p>
+          <a:p>
+            <a:pPr marL="0" indent="0" algn="just"/>
+            <a:r>
+              <a:rPr lang="en-US" altLang="en-US" sz="2000" b="1" dirty="0">
+                <a:latin typeface="Times New Roman" panose="02020603050405020304" pitchFamily="18" charset="0"/>
+                <a:ea typeface="Times New Roman" panose="02020603050405020304" pitchFamily="18" charset="0"/>
+              </a:rPr>
+              <a:t>It also aims to provide an interactive and production-ready dashboard for visualization, analysis, and decision-making using automated data pipelines and real-time forecasting techniques.</a:t>
+            </a:r>
+            <a:endParaRPr lang="en-US" altLang="en-US" sz="2000" b="1" dirty="0">
+              <a:latin typeface="Times New Roman" panose="02020603050405020304" pitchFamily="18" charset="0"/>
+              <a:ea typeface="Times New Roman" panose="02020603050405020304" pitchFamily="18" charset="0"/>
+            </a:endParaRPr>
+          </a:p>
+        </p:txBody>
+      </p:sp>
+      <p:sp>
+        <p:nvSpPr>
+          <p:cNvPr id="4" name="Slide Number Placeholder 3"/>
+          <p:cNvSpPr txBox="1">
+            <a:spLocks noGrp="1"/>
+          </p:cNvSpPr>
+          <p:nvPr>
+            <p:ph type="sldNum" sz="quarter" idx="12"/>
+          </p:nvPr>
+        </p:nvSpPr>
+        <p:spPr>
+          <a:noFill/>
+        </p:spPr>
+        <p:txBody>
+          <a:bodyPr vert="horz" lIns="91440" tIns="45720" rIns="91440" bIns="45720" rtlCol="0" anchor="ctr"/>
+          <a:lstStyle>
+            <a:lvl1pPr marL="0" lvl="0" indent="0" algn="l" defTabSz="914400" rtl="0" eaLnBrk="1" fontAlgn="base" latinLnBrk="0" hangingPunct="1">
+              <a:lnSpc>
+                <a:spcPct val="100000"/>
+              </a:lnSpc>
+              <a:spcBef>
+                <a:spcPct val="0"/>
+              </a:spcBef>
+              <a:spcAft>
+                <a:spcPct val="0"/>
+              </a:spcAft>
+              <a:buNone/>
+              <a:defRPr sz="1800" b="0" i="0" u="none" kern="1200" baseline="0">
+                <a:solidFill>
+                  <a:schemeClr val="tx1"/>
+                </a:solidFill>
+                <a:latin typeface="Calibri" panose="020F0502020204030204" pitchFamily="34" charset="0"/>
+              </a:defRPr>
+            </a:lvl1pPr>
+            <a:lvl2pPr marL="457200" lvl="1" indent="0" algn="l" defTabSz="914400" rtl="0" eaLnBrk="1" fontAlgn="base" latinLnBrk="0" hangingPunct="1">
+              <a:lnSpc>
+                <a:spcPct val="100000"/>
+              </a:lnSpc>
+              <a:spcBef>
+                <a:spcPct val="0"/>
+              </a:spcBef>
+              <a:spcAft>
+                <a:spcPct val="0"/>
+              </a:spcAft>
+              <a:buNone/>
+              <a:defRPr b="0" i="0" u="none" kern="1200" baseline="0">
+                <a:solidFill>
+                  <a:schemeClr val="tx1"/>
+                </a:solidFill>
+                <a:latin typeface="Arial" panose="020B0604020202020204" pitchFamily="34" charset="0"/>
+                <a:ea typeface="Arial" panose="020B0604020202020204" pitchFamily="34" charset="0"/>
+                <a:cs typeface="+mn-cs"/>
+              </a:defRPr>
+            </a:lvl2pPr>
+            <a:lvl3pPr marL="914400" lvl="2" indent="0" algn="l" defTabSz="914400" rtl="0" eaLnBrk="1" fontAlgn="base" latinLnBrk="0" hangingPunct="1">
+              <a:lnSpc>
+                <a:spcPct val="100000"/>
+              </a:lnSpc>
+              <a:spcBef>
+                <a:spcPct val="0"/>
+              </a:spcBef>
+              <a:spcAft>
+                <a:spcPct val="0"/>
+              </a:spcAft>
+              <a:buNone/>
+              <a:defRPr b="0" i="0" u="none" kern="1200" baseline="0">
+                <a:solidFill>
+                  <a:schemeClr val="tx1"/>
+                </a:solidFill>
+                <a:latin typeface="Arial" panose="020B0604020202020204" pitchFamily="34" charset="0"/>
+                <a:ea typeface="Arial" panose="020B0604020202020204" pitchFamily="34" charset="0"/>
+                <a:cs typeface="+mn-cs"/>
+              </a:defRPr>
+            </a:lvl3pPr>
+            <a:lvl4pPr marL="1371600" lvl="3" indent="0" algn="l" defTabSz="914400" rtl="0" eaLnBrk="1" fontAlgn="base" latinLnBrk="0" hangingPunct="1">
+              <a:lnSpc>
+                <a:spcPct val="100000"/>
+              </a:lnSpc>
+              <a:spcBef>
+                <a:spcPct val="0"/>
+              </a:spcBef>
+              <a:spcAft>
+                <a:spcPct val="0"/>
+              </a:spcAft>
+              <a:buNone/>
+              <a:defRPr b="0" i="0" u="none" kern="1200" baseline="0">
+                <a:solidFill>
+                  <a:schemeClr val="tx1"/>
+                </a:solidFill>
+                <a:latin typeface="Arial" panose="020B0604020202020204" pitchFamily="34" charset="0"/>
+                <a:ea typeface="Arial" panose="020B0604020202020204" pitchFamily="34" charset="0"/>
+                <a:cs typeface="+mn-cs"/>
+              </a:defRPr>
+            </a:lvl4pPr>
+            <a:lvl5pPr marL="1828800" lvl="4" indent="0" algn="l" defTabSz="914400" rtl="0" eaLnBrk="1" fontAlgn="base" latinLnBrk="0" hangingPunct="1">
+              <a:lnSpc>
+                <a:spcPct val="100000"/>
+              </a:lnSpc>
+              <a:spcBef>
+                <a:spcPct val="0"/>
+              </a:spcBef>
+              <a:spcAft>
+                <a:spcPct val="0"/>
+              </a:spcAft>
+              <a:buNone/>
+              <a:defRPr b="0" i="0" u="none" kern="1200" baseline="0">
+                <a:solidFill>
+                  <a:schemeClr val="tx1"/>
+                </a:solidFill>
+                <a:latin typeface="Arial" panose="020B0604020202020204" pitchFamily="34" charset="0"/>
+                <a:ea typeface="Arial" panose="020B0604020202020204" pitchFamily="34" charset="0"/>
+                <a:cs typeface="+mn-cs"/>
+              </a:defRPr>
+            </a:lvl5pPr>
+          </a:lstStyle>
+          <a:p>
+            <a:pPr lvl="0" algn="r">
+              <a:buNone/>
+            </a:pPr>
+            <a:fld id="{9A0DB2DC-4C9A-4742-B13C-FB6460FD3503}" type="slidenum">
+              <a:rPr lang="en-IN" altLang="x-none" sz="1200" dirty="0">
+                <a:solidFill>
+                  <a:srgbClr val="898989"/>
+                </a:solidFill>
+              </a:rPr>
+            </a:fld>
+            <a:endParaRPr lang="en-IN" altLang="x-none" sz="1200" dirty="0">
+              <a:solidFill>
+                <a:srgbClr val="898989"/>
+              </a:solidFill>
+            </a:endParaRPr>
+          </a:p>
+        </p:txBody>
+      </p:sp>
+      <p:pic>
+        <p:nvPicPr>
+          <p:cNvPr id="3077" name="Picture 7"/>
+          <p:cNvPicPr>
+            <a:picLocks noChangeAspect="1"/>
+          </p:cNvPicPr>
+          <p:nvPr/>
+        </p:nvPicPr>
+        <p:blipFill>
+          <a:blip r:embed="rId1"/>
+          <a:stretch>
+            <a:fillRect/>
+          </a:stretch>
+        </p:blipFill>
+        <p:spPr>
+          <a:xfrm>
+            <a:off x="0" y="5676900"/>
+            <a:ext cx="12192635" cy="1181100"/>
+          </a:xfrm>
+          <a:prstGeom prst="rect">
+            <a:avLst/>
+          </a:prstGeom>
+          <a:noFill/>
+          <a:ln w="9525">
+            <a:noFill/>
+          </a:ln>
+        </p:spPr>
+      </p:pic>
+      <p:pic>
+        <p:nvPicPr>
+          <p:cNvPr id="3078" name="Picture 2"/>
+          <p:cNvPicPr>
+            <a:picLocks noChangeAspect="1"/>
+          </p:cNvPicPr>
+          <p:nvPr/>
+        </p:nvPicPr>
+        <p:blipFill>
+          <a:blip r:embed="rId2"/>
+          <a:stretch>
+            <a:fillRect/>
+          </a:stretch>
+        </p:blipFill>
+        <p:spPr>
+          <a:xfrm>
+            <a:off x="298450" y="0"/>
+            <a:ext cx="11761788" cy="1301750"/>
+          </a:xfrm>
+          <a:prstGeom prst="rect">
+            <a:avLst/>
+          </a:prstGeom>
+          <a:noFill/>
+          <a:ln w="9525">
+            <a:noFill/>
+          </a:ln>
+        </p:spPr>
+      </p:pic>
+    </p:spTree>
+  </p:cSld>
+  <p:clrMapOvr>
+    <a:masterClrMapping/>
+  </p:clrMapOvr>
+</p:sld>
+</file>
+
+<file path=ppt/slides/slide30.xml><?xml version="1.0" encoding="utf-8"?>
 <p:sld xmlns:a="http://schemas.openxmlformats.org/drawingml/2006/main" xmlns:r="http://schemas.openxmlformats.org/officeDocument/2006/relationships" xmlns:p="http://schemas.openxmlformats.org/presentationml/2006/main">
   <p:cSld>
     <p:spTree>
@@ -16502,303 +17108,7 @@
 </p:sld>
 </file>
 
-<file path=ppt/slides/slide3.xml><?xml version="1.0" encoding="utf-8"?>
-<p:sld xmlns:a="http://schemas.openxmlformats.org/drawingml/2006/main" xmlns:r="http://schemas.openxmlformats.org/officeDocument/2006/relationships" xmlns:p="http://schemas.openxmlformats.org/presentationml/2006/main">
-  <p:cSld>
-    <p:spTree>
-      <p:nvGrpSpPr>
-        <p:cNvPr id="1" name=""/>
-        <p:cNvGrpSpPr/>
-        <p:nvPr/>
-      </p:nvGrpSpPr>
-      <p:grpSpPr/>
-      <p:sp>
-        <p:nvSpPr>
-          <p:cNvPr id="4098" name="Title 1"/>
-          <p:cNvSpPr>
-            <a:spLocks noGrp="1"/>
-          </p:cNvSpPr>
-          <p:nvPr>
-            <p:ph type="title"/>
-          </p:nvPr>
-        </p:nvSpPr>
-        <p:spPr>
-          <a:xfrm>
-            <a:off x="838200" y="989013"/>
-            <a:ext cx="10515600" cy="1325562"/>
-          </a:xfrm>
-        </p:spPr>
-        <p:txBody>
-          <a:bodyPr vert="horz" wrap="square" lIns="91440" tIns="45720" rIns="91440" bIns="45720" anchor="ctr" anchorCtr="0"/>
-          <a:p>
-            <a:pPr>
-              <a:buNone/>
-            </a:pPr>
-            <a:r>
-              <a:rPr lang="en-IN" altLang="x-none" dirty="0">
-                <a:latin typeface="Times New Roman" panose="02020603050405020304" pitchFamily="18" charset="0"/>
-                <a:cs typeface="Times New Roman" panose="02020603050405020304" pitchFamily="18" charset="0"/>
-              </a:rPr>
-              <a:t>Abstract</a:t>
-            </a:r>
-            <a:endParaRPr lang="en-IN" altLang="x-none" dirty="0">
-              <a:latin typeface="Times New Roman" panose="02020603050405020304" pitchFamily="18" charset="0"/>
-              <a:ea typeface="Times New Roman" panose="02020603050405020304" pitchFamily="18" charset="0"/>
-            </a:endParaRPr>
-          </a:p>
-        </p:txBody>
-      </p:sp>
-      <p:sp>
-        <p:nvSpPr>
-          <p:cNvPr id="4099" name="Content Placeholder 2"/>
-          <p:cNvSpPr>
-            <a:spLocks noGrp="1"/>
-          </p:cNvSpPr>
-          <p:nvPr>
-            <p:ph idx="1"/>
-          </p:nvPr>
-        </p:nvSpPr>
-        <p:spPr>
-          <a:xfrm>
-            <a:off x="838200" y="2006600"/>
-            <a:ext cx="10515600" cy="4273550"/>
-          </a:xfrm>
-        </p:spPr>
-        <p:txBody>
-          <a:bodyPr vert="horz" wrap="square" lIns="91440" tIns="45720" rIns="91440" bIns="45720" anchor="t" anchorCtr="0"/>
-          <a:p>
-            <a:pPr algn="just"/>
-            <a:r>
-              <a:rPr lang="en-US" altLang="en-US" sz="1800" dirty="0"/>
-              <a:t>Gold is a reliable investment asset, but forecasting its price is challenging due to market volatility and complex time-series patterns.</a:t>
-            </a:r>
-            <a:endParaRPr lang="en-US" altLang="en-US" sz="1800" dirty="0"/>
-          </a:p>
-          <a:p>
-            <a:pPr algn="just"/>
-            <a:r>
-              <a:rPr lang="en-US" altLang="en-US" sz="1800" dirty="0"/>
-              <a:t>This project proposes an advanced gold price forecasting system using an ensemble of Chronos-T5 and N-HiTS models to improve prediction accuracy and stability across multiple horizons, including next-day, next-week, and next-month forecasts.</a:t>
-            </a:r>
-            <a:endParaRPr lang="en-US" altLang="en-US" sz="1800" dirty="0"/>
-          </a:p>
-          <a:p>
-            <a:pPr algn="just"/>
-            <a:r>
-              <a:rPr lang="en-US" altLang="en-US" sz="1800" dirty="0"/>
-              <a:t>The system integrates data ingestion, preprocessing, feature engineering, model evaluation, and visualization into a complete end-to-end pipeline.</a:t>
-            </a:r>
-            <a:endParaRPr lang="en-US" altLang="en-US" sz="1800" dirty="0"/>
-          </a:p>
-          <a:p>
-            <a:pPr algn="just"/>
-            <a:r>
-              <a:rPr lang="en-US" altLang="en-US" sz="1800" dirty="0"/>
-              <a:t>SQLite is used for cost-effective local storage, and a Streamlit dashboard provides interactive forecasting and analysis for investors.</a:t>
-            </a:r>
-            <a:endParaRPr lang="en-US" altLang="en-US" sz="1800" dirty="0"/>
-          </a:p>
-        </p:txBody>
-      </p:sp>
-      <p:sp>
-        <p:nvSpPr>
-          <p:cNvPr id="4" name="Slide Number Placeholder 3"/>
-          <p:cNvSpPr txBox="1">
-            <a:spLocks noGrp="1"/>
-          </p:cNvSpPr>
-          <p:nvPr>
-            <p:ph type="sldNum" sz="quarter" idx="12"/>
-          </p:nvPr>
-        </p:nvSpPr>
-        <p:spPr>
-          <a:noFill/>
-        </p:spPr>
-        <p:txBody>
-          <a:bodyPr vert="horz" lIns="91440" tIns="45720" rIns="91440" bIns="45720" rtlCol="0" anchor="ctr"/>
-          <a:lstStyle>
-            <a:lvl1pPr marL="0" lvl="0" indent="0" algn="l" defTabSz="914400" rtl="0" eaLnBrk="1" fontAlgn="base" latinLnBrk="0" hangingPunct="1">
-              <a:lnSpc>
-                <a:spcPct val="100000"/>
-              </a:lnSpc>
-              <a:spcBef>
-                <a:spcPct val="0"/>
-              </a:spcBef>
-              <a:spcAft>
-                <a:spcPct val="0"/>
-              </a:spcAft>
-              <a:buNone/>
-              <a:defRPr sz="1800" b="0" i="0" u="none" kern="1200" baseline="0">
-                <a:solidFill>
-                  <a:schemeClr val="tx1"/>
-                </a:solidFill>
-                <a:latin typeface="Calibri" panose="020F0502020204030204" pitchFamily="34" charset="0"/>
-              </a:defRPr>
-            </a:lvl1pPr>
-            <a:lvl2pPr marL="457200" lvl="1" indent="0" algn="l" defTabSz="914400" rtl="0" eaLnBrk="1" fontAlgn="base" latinLnBrk="0" hangingPunct="1">
-              <a:lnSpc>
-                <a:spcPct val="100000"/>
-              </a:lnSpc>
-              <a:spcBef>
-                <a:spcPct val="0"/>
-              </a:spcBef>
-              <a:spcAft>
-                <a:spcPct val="0"/>
-              </a:spcAft>
-              <a:buNone/>
-              <a:defRPr b="0" i="0" u="none" kern="1200" baseline="0">
-                <a:solidFill>
-                  <a:schemeClr val="tx1"/>
-                </a:solidFill>
-                <a:latin typeface="Arial" panose="020B0604020202020204" pitchFamily="34" charset="0"/>
-                <a:ea typeface="Arial" panose="020B0604020202020204" pitchFamily="34" charset="0"/>
-                <a:cs typeface="+mn-cs"/>
-              </a:defRPr>
-            </a:lvl2pPr>
-            <a:lvl3pPr marL="914400" lvl="2" indent="0" algn="l" defTabSz="914400" rtl="0" eaLnBrk="1" fontAlgn="base" latinLnBrk="0" hangingPunct="1">
-              <a:lnSpc>
-                <a:spcPct val="100000"/>
-              </a:lnSpc>
-              <a:spcBef>
-                <a:spcPct val="0"/>
-              </a:spcBef>
-              <a:spcAft>
-                <a:spcPct val="0"/>
-              </a:spcAft>
-              <a:buNone/>
-              <a:defRPr b="0" i="0" u="none" kern="1200" baseline="0">
-                <a:solidFill>
-                  <a:schemeClr val="tx1"/>
-                </a:solidFill>
-                <a:latin typeface="Arial" panose="020B0604020202020204" pitchFamily="34" charset="0"/>
-                <a:ea typeface="Arial" panose="020B0604020202020204" pitchFamily="34" charset="0"/>
-                <a:cs typeface="+mn-cs"/>
-              </a:defRPr>
-            </a:lvl3pPr>
-            <a:lvl4pPr marL="1371600" lvl="3" indent="0" algn="l" defTabSz="914400" rtl="0" eaLnBrk="1" fontAlgn="base" latinLnBrk="0" hangingPunct="1">
-              <a:lnSpc>
-                <a:spcPct val="100000"/>
-              </a:lnSpc>
-              <a:spcBef>
-                <a:spcPct val="0"/>
-              </a:spcBef>
-              <a:spcAft>
-                <a:spcPct val="0"/>
-              </a:spcAft>
-              <a:buNone/>
-              <a:defRPr b="0" i="0" u="none" kern="1200" baseline="0">
-                <a:solidFill>
-                  <a:schemeClr val="tx1"/>
-                </a:solidFill>
-                <a:latin typeface="Arial" panose="020B0604020202020204" pitchFamily="34" charset="0"/>
-                <a:ea typeface="Arial" panose="020B0604020202020204" pitchFamily="34" charset="0"/>
-                <a:cs typeface="+mn-cs"/>
-              </a:defRPr>
-            </a:lvl4pPr>
-            <a:lvl5pPr marL="1828800" lvl="4" indent="0" algn="l" defTabSz="914400" rtl="0" eaLnBrk="1" fontAlgn="base" latinLnBrk="0" hangingPunct="1">
-              <a:lnSpc>
-                <a:spcPct val="100000"/>
-              </a:lnSpc>
-              <a:spcBef>
-                <a:spcPct val="0"/>
-              </a:spcBef>
-              <a:spcAft>
-                <a:spcPct val="0"/>
-              </a:spcAft>
-              <a:buNone/>
-              <a:defRPr b="0" i="0" u="none" kern="1200" baseline="0">
-                <a:solidFill>
-                  <a:schemeClr val="tx1"/>
-                </a:solidFill>
-                <a:latin typeface="Arial" panose="020B0604020202020204" pitchFamily="34" charset="0"/>
-                <a:ea typeface="Arial" panose="020B0604020202020204" pitchFamily="34" charset="0"/>
-                <a:cs typeface="+mn-cs"/>
-              </a:defRPr>
-            </a:lvl5pPr>
-          </a:lstStyle>
-          <a:p>
-            <a:pPr lvl="0" algn="r">
-              <a:buNone/>
-            </a:pPr>
-            <a:fld id="{9A0DB2DC-4C9A-4742-B13C-FB6460FD3503}" type="slidenum">
-              <a:rPr lang="en-IN" altLang="x-none" sz="1200" dirty="0">
-                <a:solidFill>
-                  <a:srgbClr val="898989"/>
-                </a:solidFill>
-              </a:rPr>
-            </a:fld>
-            <a:endParaRPr lang="en-IN" altLang="x-none" sz="1200" dirty="0">
-              <a:solidFill>
-                <a:srgbClr val="898989"/>
-              </a:solidFill>
-            </a:endParaRPr>
-          </a:p>
-        </p:txBody>
-      </p:sp>
-      <p:pic>
-        <p:nvPicPr>
-          <p:cNvPr id="4101" name="Picture 2"/>
-          <p:cNvPicPr>
-            <a:picLocks noChangeAspect="1"/>
-          </p:cNvPicPr>
-          <p:nvPr/>
-        </p:nvPicPr>
-        <p:blipFill>
-          <a:blip r:embed="rId1"/>
-          <a:stretch>
-            <a:fillRect/>
-          </a:stretch>
-        </p:blipFill>
-        <p:spPr>
-          <a:xfrm>
-            <a:off x="201613" y="0"/>
-            <a:ext cx="11761787" cy="1301750"/>
-          </a:xfrm>
-          <a:prstGeom prst="rect">
-            <a:avLst/>
-          </a:prstGeom>
-          <a:noFill/>
-          <a:ln w="9525">
-            <a:noFill/>
-          </a:ln>
-        </p:spPr>
-      </p:pic>
-      <p:pic>
-        <p:nvPicPr>
-          <p:cNvPr id="13317" name="Picture 6"/>
-          <p:cNvPicPr>
-            <a:picLocks noChangeAspect="1"/>
-          </p:cNvPicPr>
-          <p:nvPr/>
-        </p:nvPicPr>
-        <p:blipFill>
-          <a:blip r:embed="rId2"/>
-          <a:stretch>
-            <a:fillRect/>
-          </a:stretch>
-        </p:blipFill>
-        <p:spPr>
-          <a:xfrm>
-            <a:off x="0" y="5676900"/>
-            <a:ext cx="12192000" cy="1181100"/>
-          </a:xfrm>
-          <a:prstGeom prst="rect">
-            <a:avLst/>
-          </a:prstGeom>
-          <a:noFill/>
-          <a:ln w="9525">
-            <a:noFill/>
-          </a:ln>
-        </p:spPr>
-      </p:pic>
-    </p:spTree>
-  </p:cSld>
-  <p:clrMapOvr>
-    <a:masterClrMapping/>
-  </p:clrMapOvr>
-</p:sld>
-</file>
-
-<file path=ppt/slides/slide30.xml><?xml version="1.0" encoding="utf-8"?>
+<file path=ppt/slides/slide31.xml><?xml version="1.0" encoding="utf-8"?>
 <p:sld xmlns:a="http://schemas.openxmlformats.org/drawingml/2006/main" xmlns:r="http://schemas.openxmlformats.org/officeDocument/2006/relationships" xmlns:p="http://schemas.openxmlformats.org/presentationml/2006/main">
   <p:cSld>
     <p:spTree>
@@ -16909,6 +17219,403 @@
 </file>
 
 <file path=ppt/slides/slide4.xml><?xml version="1.0" encoding="utf-8"?>
+<p:sld xmlns:a="http://schemas.openxmlformats.org/drawingml/2006/main" xmlns:r="http://schemas.openxmlformats.org/officeDocument/2006/relationships" xmlns:p="http://schemas.openxmlformats.org/presentationml/2006/main">
+  <p:cSld>
+    <p:spTree>
+      <p:nvGrpSpPr>
+        <p:cNvPr id="1" name=""/>
+        <p:cNvGrpSpPr/>
+        <p:nvPr/>
+      </p:nvGrpSpPr>
+      <p:grpSpPr/>
+      <p:sp>
+        <p:nvSpPr>
+          <p:cNvPr id="3074" name="Title 1"/>
+          <p:cNvSpPr>
+            <a:spLocks noGrp="1"/>
+          </p:cNvSpPr>
+          <p:nvPr>
+            <p:ph type="title"/>
+          </p:nvPr>
+        </p:nvSpPr>
+        <p:spPr>
+          <a:xfrm>
+            <a:off x="797878" y="1010920"/>
+            <a:ext cx="10515600" cy="1325563"/>
+          </a:xfrm>
+        </p:spPr>
+        <p:txBody>
+          <a:bodyPr vert="horz" wrap="square" lIns="91440" tIns="45720" rIns="91440" bIns="45720" anchor="ctr" anchorCtr="0"/>
+          <a:p>
+            <a:pPr>
+              <a:buNone/>
+            </a:pPr>
+            <a:r>
+              <a:rPr lang="en-IN" altLang="x-none" dirty="0">
+                <a:latin typeface="Times New Roman" panose="02020603050405020304" pitchFamily="18" charset="0"/>
+                <a:cs typeface="Times New Roman" panose="02020603050405020304" pitchFamily="18" charset="0"/>
+              </a:rPr>
+              <a:t>Problem Statement</a:t>
+            </a:r>
+            <a:endParaRPr lang="en-IN" altLang="x-none" dirty="0">
+              <a:latin typeface="Times New Roman" panose="02020603050405020304" pitchFamily="18" charset="0"/>
+              <a:ea typeface="Times New Roman" panose="02020603050405020304" pitchFamily="18" charset="0"/>
+            </a:endParaRPr>
+          </a:p>
+        </p:txBody>
+      </p:sp>
+      <p:sp>
+        <p:nvSpPr>
+          <p:cNvPr id="3075" name="Content Placeholder 2"/>
+          <p:cNvSpPr>
+            <a:spLocks noGrp="1"/>
+          </p:cNvSpPr>
+          <p:nvPr>
+            <p:ph idx="1"/>
+          </p:nvPr>
+        </p:nvSpPr>
+        <p:spPr>
+          <a:xfrm>
+            <a:off x="838200" y="2061210"/>
+            <a:ext cx="10515600" cy="4176713"/>
+          </a:xfrm>
+        </p:spPr>
+        <p:txBody>
+          <a:bodyPr vert="horz" wrap="square" lIns="91440" tIns="45720" rIns="91440" bIns="45720" anchor="t" anchorCtr="0"/>
+          <a:p>
+            <a:pPr marL="0" indent="0" algn="just"/>
+            <a:r>
+              <a:rPr lang="en-US" altLang="en-US" sz="1700" b="1" dirty="0">
+                <a:latin typeface="Times New Roman" panose="02020603050405020304" pitchFamily="18" charset="0"/>
+                <a:ea typeface="Times New Roman" panose="02020603050405020304" pitchFamily="18" charset="0"/>
+              </a:rPr>
+              <a:t>Volatile, multi-driver market: </a:t>
+            </a:r>
+            <a:r>
+              <a:rPr lang="en-US" altLang="en-US" sz="1700" dirty="0">
+                <a:latin typeface="Times New Roman" panose="02020603050405020304" pitchFamily="18" charset="0"/>
+                <a:ea typeface="Times New Roman" panose="02020603050405020304" pitchFamily="18" charset="0"/>
+              </a:rPr>
+              <a:t>Gold prices react to currency moves, geopolitics, inflation, and demand–supply shifts, making simple heuristics unreliable.</a:t>
+            </a:r>
+            <a:endParaRPr lang="en-US" altLang="en-US" sz="1700" dirty="0">
+              <a:latin typeface="Times New Roman" panose="02020603050405020304" pitchFamily="18" charset="0"/>
+              <a:ea typeface="Times New Roman" panose="02020603050405020304" pitchFamily="18" charset="0"/>
+            </a:endParaRPr>
+          </a:p>
+          <a:p>
+            <a:pPr marL="0" indent="0" algn="just"/>
+            <a:r>
+              <a:rPr lang="en-US" altLang="en-US" sz="1700" b="1" dirty="0">
+                <a:latin typeface="Times New Roman" panose="02020603050405020304" pitchFamily="18" charset="0"/>
+                <a:ea typeface="Times New Roman" panose="02020603050405020304" pitchFamily="18" charset="0"/>
+              </a:rPr>
+              <a:t>Retail access gap: </a:t>
+            </a:r>
+            <a:r>
+              <a:rPr lang="en-US" altLang="en-US" sz="1700" dirty="0">
+                <a:latin typeface="Times New Roman" panose="02020603050405020304" pitchFamily="18" charset="0"/>
+                <a:ea typeface="Times New Roman" panose="02020603050405020304" pitchFamily="18" charset="0"/>
+              </a:rPr>
+              <a:t>Advanced, data-driven forecasting is mostly institutional; individual investors lack affordable, user-friendly tools.</a:t>
+            </a:r>
+            <a:endParaRPr lang="en-US" altLang="en-US" sz="1700" b="1" dirty="0">
+              <a:latin typeface="Times New Roman" panose="02020603050405020304" pitchFamily="18" charset="0"/>
+              <a:ea typeface="Times New Roman" panose="02020603050405020304" pitchFamily="18" charset="0"/>
+            </a:endParaRPr>
+          </a:p>
+          <a:p>
+            <a:pPr marL="0" indent="0" algn="just"/>
+            <a:r>
+              <a:rPr lang="en-US" altLang="en-US" sz="1700" b="1" dirty="0">
+                <a:latin typeface="Times New Roman" panose="02020603050405020304" pitchFamily="18" charset="0"/>
+                <a:ea typeface="Times New Roman" panose="02020603050405020304" pitchFamily="18" charset="0"/>
+              </a:rPr>
+              <a:t>Weak traditional models: </a:t>
+            </a:r>
+            <a:r>
+              <a:rPr lang="en-US" altLang="en-US" sz="1700" dirty="0">
+                <a:latin typeface="Times New Roman" panose="02020603050405020304" pitchFamily="18" charset="0"/>
+                <a:ea typeface="Times New Roman" panose="02020603050405020304" pitchFamily="18" charset="0"/>
+              </a:rPr>
+              <a:t>ARIMA and standalone LSTM often overfit, struggle with regime changes, and need heavy manual feature engineering.</a:t>
+            </a:r>
+            <a:endParaRPr lang="en-US" altLang="en-US" sz="1700" dirty="0">
+              <a:latin typeface="Times New Roman" panose="02020603050405020304" pitchFamily="18" charset="0"/>
+              <a:ea typeface="Times New Roman" panose="02020603050405020304" pitchFamily="18" charset="0"/>
+            </a:endParaRPr>
+          </a:p>
+          <a:p>
+            <a:pPr marL="0" indent="0" algn="just"/>
+            <a:r>
+              <a:rPr lang="en-US" altLang="en-US" sz="1700" b="1" dirty="0">
+                <a:latin typeface="Times New Roman" panose="02020603050405020304" pitchFamily="18" charset="0"/>
+                <a:ea typeface="Times New Roman" panose="02020603050405020304" pitchFamily="18" charset="0"/>
+              </a:rPr>
+              <a:t>Single-horizon focus: </a:t>
+            </a:r>
+            <a:r>
+              <a:rPr lang="en-US" altLang="en-US" sz="1700" dirty="0">
+                <a:latin typeface="Times New Roman" panose="02020603050405020304" pitchFamily="18" charset="0"/>
+                <a:ea typeface="Times New Roman" panose="02020603050405020304" pitchFamily="18" charset="0"/>
+              </a:rPr>
+              <a:t>Most tools target short-term only, leaving medium/long-term (weeks to years) planning unsupported.</a:t>
+            </a:r>
+            <a:endParaRPr lang="en-US" altLang="en-US" sz="1700" dirty="0">
+              <a:latin typeface="Times New Roman" panose="02020603050405020304" pitchFamily="18" charset="0"/>
+              <a:ea typeface="Times New Roman" panose="02020603050405020304" pitchFamily="18" charset="0"/>
+            </a:endParaRPr>
+          </a:p>
+          <a:p>
+            <a:pPr marL="0" indent="0" algn="just"/>
+            <a:r>
+              <a:rPr lang="en-US" altLang="en-US" sz="1700" b="1" dirty="0">
+                <a:latin typeface="Times New Roman" panose="02020603050405020304" pitchFamily="18" charset="0"/>
+                <a:ea typeface="Times New Roman" panose="02020603050405020304" pitchFamily="18" charset="0"/>
+              </a:rPr>
+              <a:t>Not investor-ready: </a:t>
+            </a:r>
+            <a:r>
+              <a:rPr lang="en-US" altLang="en-US" sz="1700" dirty="0">
+                <a:latin typeface="Times New Roman" panose="02020603050405020304" pitchFamily="18" charset="0"/>
+                <a:ea typeface="Times New Roman" panose="02020603050405020304" pitchFamily="18" charset="0"/>
+              </a:rPr>
+              <a:t>Outputs are statistical, not actionable (e.g., no custom weight-based cost estimates or USD→INR conversions).</a:t>
+            </a:r>
+            <a:endParaRPr lang="en-US" altLang="en-US" sz="1700" dirty="0">
+              <a:latin typeface="Times New Roman" panose="02020603050405020304" pitchFamily="18" charset="0"/>
+              <a:ea typeface="Times New Roman" panose="02020603050405020304" pitchFamily="18" charset="0"/>
+            </a:endParaRPr>
+          </a:p>
+          <a:p>
+            <a:pPr marL="0" indent="0" algn="just"/>
+            <a:r>
+              <a:rPr lang="en-US" altLang="en-US" sz="1700" b="1" dirty="0">
+                <a:latin typeface="Times New Roman" panose="02020603050405020304" pitchFamily="18" charset="0"/>
+                <a:ea typeface="Times New Roman" panose="02020603050405020304" pitchFamily="18" charset="0"/>
+              </a:rPr>
+              <a:t>High deployment cost: </a:t>
+            </a:r>
+            <a:r>
+              <a:rPr lang="en-US" altLang="en-US" sz="1700" dirty="0">
+                <a:latin typeface="Times New Roman" panose="02020603050405020304" pitchFamily="18" charset="0"/>
+                <a:ea typeface="Times New Roman" panose="02020603050405020304" pitchFamily="18" charset="0"/>
+              </a:rPr>
+              <a:t>Reliable, continuously updating systems usually require expensive cloud infrastructure, blocking small-scale users.</a:t>
+            </a:r>
+            <a:endParaRPr lang="en-US" altLang="en-US" sz="1700" dirty="0">
+              <a:latin typeface="Times New Roman" panose="02020603050405020304" pitchFamily="18" charset="0"/>
+              <a:ea typeface="Times New Roman" panose="02020603050405020304" pitchFamily="18" charset="0"/>
+            </a:endParaRPr>
+          </a:p>
+          <a:p>
+            <a:pPr marL="0" indent="0" algn="just"/>
+            <a:endParaRPr lang="en-US" altLang="en-US" sz="1700" dirty="0">
+              <a:latin typeface="Times New Roman" panose="02020603050405020304" pitchFamily="18" charset="0"/>
+              <a:ea typeface="Times New Roman" panose="02020603050405020304" pitchFamily="18" charset="0"/>
+            </a:endParaRPr>
+          </a:p>
+        </p:txBody>
+      </p:sp>
+      <p:sp>
+        <p:nvSpPr>
+          <p:cNvPr id="4" name="Slide Number Placeholder 3"/>
+          <p:cNvSpPr txBox="1">
+            <a:spLocks noGrp="1"/>
+          </p:cNvSpPr>
+          <p:nvPr>
+            <p:ph type="sldNum" sz="quarter" idx="12"/>
+          </p:nvPr>
+        </p:nvSpPr>
+        <p:spPr>
+          <a:noFill/>
+        </p:spPr>
+        <p:txBody>
+          <a:bodyPr vert="horz" lIns="91440" tIns="45720" rIns="91440" bIns="45720" rtlCol="0" anchor="ctr"/>
+          <a:lstStyle>
+            <a:lvl1pPr marL="0" lvl="0" indent="0" algn="l" defTabSz="914400" rtl="0" eaLnBrk="1" fontAlgn="base" latinLnBrk="0" hangingPunct="1">
+              <a:lnSpc>
+                <a:spcPct val="100000"/>
+              </a:lnSpc>
+              <a:spcBef>
+                <a:spcPct val="0"/>
+              </a:spcBef>
+              <a:spcAft>
+                <a:spcPct val="0"/>
+              </a:spcAft>
+              <a:buNone/>
+              <a:defRPr sz="1800" b="0" i="0" u="none" kern="1200" baseline="0">
+                <a:solidFill>
+                  <a:schemeClr val="tx1"/>
+                </a:solidFill>
+                <a:latin typeface="Calibri" panose="020F0502020204030204" pitchFamily="34" charset="0"/>
+              </a:defRPr>
+            </a:lvl1pPr>
+            <a:lvl2pPr marL="457200" lvl="1" indent="0" algn="l" defTabSz="914400" rtl="0" eaLnBrk="1" fontAlgn="base" latinLnBrk="0" hangingPunct="1">
+              <a:lnSpc>
+                <a:spcPct val="100000"/>
+              </a:lnSpc>
+              <a:spcBef>
+                <a:spcPct val="0"/>
+              </a:spcBef>
+              <a:spcAft>
+                <a:spcPct val="0"/>
+              </a:spcAft>
+              <a:buNone/>
+              <a:defRPr b="0" i="0" u="none" kern="1200" baseline="0">
+                <a:solidFill>
+                  <a:schemeClr val="tx1"/>
+                </a:solidFill>
+                <a:latin typeface="Arial" panose="020B0604020202020204" pitchFamily="34" charset="0"/>
+                <a:ea typeface="Arial" panose="020B0604020202020204" pitchFamily="34" charset="0"/>
+                <a:cs typeface="+mn-cs"/>
+              </a:defRPr>
+            </a:lvl2pPr>
+            <a:lvl3pPr marL="914400" lvl="2" indent="0" algn="l" defTabSz="914400" rtl="0" eaLnBrk="1" fontAlgn="base" latinLnBrk="0" hangingPunct="1">
+              <a:lnSpc>
+                <a:spcPct val="100000"/>
+              </a:lnSpc>
+              <a:spcBef>
+                <a:spcPct val="0"/>
+              </a:spcBef>
+              <a:spcAft>
+                <a:spcPct val="0"/>
+              </a:spcAft>
+              <a:buNone/>
+              <a:defRPr b="0" i="0" u="none" kern="1200" baseline="0">
+                <a:solidFill>
+                  <a:schemeClr val="tx1"/>
+                </a:solidFill>
+                <a:latin typeface="Arial" panose="020B0604020202020204" pitchFamily="34" charset="0"/>
+                <a:ea typeface="Arial" panose="020B0604020202020204" pitchFamily="34" charset="0"/>
+                <a:cs typeface="+mn-cs"/>
+              </a:defRPr>
+            </a:lvl3pPr>
+            <a:lvl4pPr marL="1371600" lvl="3" indent="0" algn="l" defTabSz="914400" rtl="0" eaLnBrk="1" fontAlgn="base" latinLnBrk="0" hangingPunct="1">
+              <a:lnSpc>
+                <a:spcPct val="100000"/>
+              </a:lnSpc>
+              <a:spcBef>
+                <a:spcPct val="0"/>
+              </a:spcBef>
+              <a:spcAft>
+                <a:spcPct val="0"/>
+              </a:spcAft>
+              <a:buNone/>
+              <a:defRPr b="0" i="0" u="none" kern="1200" baseline="0">
+                <a:solidFill>
+                  <a:schemeClr val="tx1"/>
+                </a:solidFill>
+                <a:latin typeface="Arial" panose="020B0604020202020204" pitchFamily="34" charset="0"/>
+                <a:ea typeface="Arial" panose="020B0604020202020204" pitchFamily="34" charset="0"/>
+                <a:cs typeface="+mn-cs"/>
+              </a:defRPr>
+            </a:lvl4pPr>
+            <a:lvl5pPr marL="1828800" lvl="4" indent="0" algn="l" defTabSz="914400" rtl="0" eaLnBrk="1" fontAlgn="base" latinLnBrk="0" hangingPunct="1">
+              <a:lnSpc>
+                <a:spcPct val="100000"/>
+              </a:lnSpc>
+              <a:spcBef>
+                <a:spcPct val="0"/>
+              </a:spcBef>
+              <a:spcAft>
+                <a:spcPct val="0"/>
+              </a:spcAft>
+              <a:buNone/>
+              <a:defRPr b="0" i="0" u="none" kern="1200" baseline="0">
+                <a:solidFill>
+                  <a:schemeClr val="tx1"/>
+                </a:solidFill>
+                <a:latin typeface="Arial" panose="020B0604020202020204" pitchFamily="34" charset="0"/>
+                <a:ea typeface="Arial" panose="020B0604020202020204" pitchFamily="34" charset="0"/>
+                <a:cs typeface="+mn-cs"/>
+              </a:defRPr>
+            </a:lvl5pPr>
+          </a:lstStyle>
+          <a:p>
+            <a:pPr lvl="0" algn="r">
+              <a:buNone/>
+            </a:pPr>
+            <a:fld id="{9A0DB2DC-4C9A-4742-B13C-FB6460FD3503}" type="slidenum">
+              <a:rPr lang="en-IN" altLang="x-none" sz="1200" dirty="0">
+                <a:solidFill>
+                  <a:srgbClr val="898989"/>
+                </a:solidFill>
+              </a:rPr>
+            </a:fld>
+            <a:endParaRPr lang="en-IN" altLang="x-none" sz="1200" dirty="0">
+              <a:solidFill>
+                <a:srgbClr val="898989"/>
+              </a:solidFill>
+            </a:endParaRPr>
+          </a:p>
+        </p:txBody>
+      </p:sp>
+      <p:pic>
+        <p:nvPicPr>
+          <p:cNvPr id="3077" name="Picture 7"/>
+          <p:cNvPicPr>
+            <a:picLocks noChangeAspect="1"/>
+          </p:cNvPicPr>
+          <p:nvPr/>
+        </p:nvPicPr>
+        <p:blipFill>
+          <a:blip r:embed="rId1"/>
+          <a:stretch>
+            <a:fillRect/>
+          </a:stretch>
+        </p:blipFill>
+        <p:spPr>
+          <a:xfrm>
+            <a:off x="0" y="5676900"/>
+            <a:ext cx="12192635" cy="1181100"/>
+          </a:xfrm>
+          <a:prstGeom prst="rect">
+            <a:avLst/>
+          </a:prstGeom>
+          <a:noFill/>
+          <a:ln w="9525">
+            <a:noFill/>
+          </a:ln>
+        </p:spPr>
+      </p:pic>
+      <p:pic>
+        <p:nvPicPr>
+          <p:cNvPr id="3078" name="Picture 2"/>
+          <p:cNvPicPr>
+            <a:picLocks noChangeAspect="1"/>
+          </p:cNvPicPr>
+          <p:nvPr/>
+        </p:nvPicPr>
+        <p:blipFill>
+          <a:blip r:embed="rId2"/>
+          <a:stretch>
+            <a:fillRect/>
+          </a:stretch>
+        </p:blipFill>
+        <p:spPr>
+          <a:xfrm>
+            <a:off x="298450" y="0"/>
+            <a:ext cx="11761788" cy="1301750"/>
+          </a:xfrm>
+          <a:prstGeom prst="rect">
+            <a:avLst/>
+          </a:prstGeom>
+          <a:noFill/>
+          <a:ln w="9525">
+            <a:noFill/>
+          </a:ln>
+        </p:spPr>
+      </p:pic>
+    </p:spTree>
+  </p:cSld>
+  <p:clrMapOvr>
+    <a:masterClrMapping/>
+  </p:clrMapOvr>
+</p:sld>
+</file>
+
+<file path=ppt/slides/slide5.xml><?xml version="1.0" encoding="utf-8"?>
 <p:sld xmlns:a="http://schemas.openxmlformats.org/drawingml/2006/main" xmlns:r="http://schemas.openxmlformats.org/officeDocument/2006/relationships" xmlns:p="http://schemas.openxmlformats.org/presentationml/2006/main">
   <p:cSld>
     <p:spTree>
@@ -17580,7 +18287,7 @@
 </p:sld>
 </file>
 
-<file path=ppt/slides/slide5.xml><?xml version="1.0" encoding="utf-8"?>
+<file path=ppt/slides/slide6.xml><?xml version="1.0" encoding="utf-8"?>
 <p:sld xmlns:a="http://schemas.openxmlformats.org/drawingml/2006/main" xmlns:r="http://schemas.openxmlformats.org/officeDocument/2006/relationships" xmlns:p="http://schemas.openxmlformats.org/presentationml/2006/main">
   <p:cSld>
     <p:spTree>
@@ -18168,7 +18875,7 @@
 </p:sld>
 </file>
 
-<file path=ppt/slides/slide6.xml><?xml version="1.0" encoding="utf-8"?>
+<file path=ppt/slides/slide7.xml><?xml version="1.0" encoding="utf-8"?>
 <p:sld xmlns:a="http://schemas.openxmlformats.org/drawingml/2006/main" xmlns:r="http://schemas.openxmlformats.org/officeDocument/2006/relationships" xmlns:p="http://schemas.openxmlformats.org/presentationml/2006/main">
   <p:cSld>
     <p:spTree>
@@ -18738,7 +19445,7 @@
 </p:sld>
 </file>
 
-<file path=ppt/slides/slide7.xml><?xml version="1.0" encoding="utf-8"?>
+<file path=ppt/slides/slide8.xml><?xml version="1.0" encoding="utf-8"?>
 <p:sld xmlns:a="http://schemas.openxmlformats.org/drawingml/2006/main" xmlns:r="http://schemas.openxmlformats.org/officeDocument/2006/relationships" xmlns:p="http://schemas.openxmlformats.org/presentationml/2006/main">
   <p:cSld>
     <p:spTree>
@@ -19328,7 +20035,7 @@
 </p:sld>
 </file>
 
-<file path=ppt/slides/slide8.xml><?xml version="1.0" encoding="utf-8"?>
+<file path=ppt/slides/slide9.xml><?xml version="1.0" encoding="utf-8"?>
 <p:sld xmlns:a="http://schemas.openxmlformats.org/drawingml/2006/main" xmlns:r="http://schemas.openxmlformats.org/officeDocument/2006/relationships" xmlns:p="http://schemas.openxmlformats.org/presentationml/2006/main">
   <p:cSld>
     <p:spTree>
@@ -19872,315 +20579,6 @@
           <a:xfrm>
             <a:off x="0" y="5676900"/>
             <a:ext cx="12192000" cy="1181100"/>
-          </a:xfrm>
-          <a:prstGeom prst="rect">
-            <a:avLst/>
-          </a:prstGeom>
-          <a:noFill/>
-          <a:ln w="9525">
-            <a:noFill/>
-          </a:ln>
-        </p:spPr>
-      </p:pic>
-      <p:pic>
-        <p:nvPicPr>
-          <p:cNvPr id="10246" name="Picture 2"/>
-          <p:cNvPicPr>
-            <a:picLocks noChangeAspect="1"/>
-          </p:cNvPicPr>
-          <p:nvPr/>
-        </p:nvPicPr>
-        <p:blipFill>
-          <a:blip r:embed="rId2"/>
-          <a:stretch>
-            <a:fillRect/>
-          </a:stretch>
-        </p:blipFill>
-        <p:spPr>
-          <a:xfrm>
-            <a:off x="149225" y="0"/>
-            <a:ext cx="11761788" cy="1301750"/>
-          </a:xfrm>
-          <a:prstGeom prst="rect">
-            <a:avLst/>
-          </a:prstGeom>
-          <a:noFill/>
-          <a:ln w="9525">
-            <a:noFill/>
-          </a:ln>
-        </p:spPr>
-      </p:pic>
-    </p:spTree>
-  </p:cSld>
-  <p:clrMapOvr>
-    <a:masterClrMapping/>
-  </p:clrMapOvr>
-</p:sld>
-</file>
-
-<file path=ppt/slides/slide9.xml><?xml version="1.0" encoding="utf-8"?>
-<p:sld xmlns:a="http://schemas.openxmlformats.org/drawingml/2006/main" xmlns:r="http://schemas.openxmlformats.org/officeDocument/2006/relationships" xmlns:p="http://schemas.openxmlformats.org/presentationml/2006/main">
-  <p:cSld>
-    <p:spTree>
-      <p:nvGrpSpPr>
-        <p:cNvPr id="1" name=""/>
-        <p:cNvGrpSpPr/>
-        <p:nvPr/>
-      </p:nvGrpSpPr>
-      <p:grpSpPr/>
-      <p:sp>
-        <p:nvSpPr>
-          <p:cNvPr id="10242" name="Title 1"/>
-          <p:cNvSpPr>
-            <a:spLocks noGrp="1"/>
-          </p:cNvSpPr>
-          <p:nvPr>
-            <p:ph type="title"/>
-          </p:nvPr>
-        </p:nvSpPr>
-        <p:spPr>
-          <a:xfrm>
-            <a:off x="838200" y="1296988"/>
-            <a:ext cx="10515600" cy="708025"/>
-          </a:xfrm>
-        </p:spPr>
-        <p:txBody>
-          <a:bodyPr vert="horz" wrap="square" lIns="91440" tIns="45720" rIns="91440" bIns="45720" anchor="ctr" anchorCtr="0"/>
-          <a:p>
-            <a:pPr>
-              <a:buNone/>
-            </a:pPr>
-            <a:br>
-              <a:rPr lang="en-IN" altLang="x-none" dirty="0">
-                <a:latin typeface="Times New Roman" panose="02020603050405020304" pitchFamily="18" charset="0"/>
-                <a:cs typeface="Times New Roman" panose="02020603050405020304" pitchFamily="18" charset="0"/>
-              </a:rPr>
-            </a:br>
-            <a:r>
-              <a:rPr lang="en-IN" altLang="x-none" dirty="0">
-                <a:latin typeface="Times New Roman" panose="02020603050405020304" pitchFamily="18" charset="0"/>
-                <a:cs typeface="Times New Roman" panose="02020603050405020304" pitchFamily="18" charset="0"/>
-              </a:rPr>
-              <a:t>Existing System</a:t>
-            </a:r>
-            <a:endParaRPr lang="en-IN" altLang="x-none" dirty="0">
-              <a:latin typeface="Times New Roman" panose="02020603050405020304" pitchFamily="18" charset="0"/>
-              <a:ea typeface="Times New Roman" panose="02020603050405020304" pitchFamily="18" charset="0"/>
-            </a:endParaRPr>
-          </a:p>
-        </p:txBody>
-      </p:sp>
-      <p:sp>
-        <p:nvSpPr>
-          <p:cNvPr id="10243" name="Content Placeholder 2"/>
-          <p:cNvSpPr>
-            <a:spLocks noGrp="1"/>
-          </p:cNvSpPr>
-          <p:nvPr>
-            <p:ph idx="1"/>
-          </p:nvPr>
-        </p:nvSpPr>
-        <p:spPr>
-          <a:xfrm>
-            <a:off x="838200" y="2499360"/>
-            <a:ext cx="10515600" cy="4552950"/>
-          </a:xfrm>
-        </p:spPr>
-        <p:txBody>
-          <a:bodyPr vert="horz" wrap="square" lIns="91440" tIns="45720" rIns="91440" bIns="45720" anchor="t" anchorCtr="0"/>
-          <a:p>
-            <a:r>
-              <a:rPr lang="en-US" altLang="en-US" sz="2000" dirty="0">
-                <a:latin typeface="Times New Roman" panose="02020603050405020304" pitchFamily="18" charset="0"/>
-                <a:ea typeface="Times New Roman" panose="02020603050405020304" pitchFamily="18" charset="0"/>
-              </a:rPr>
-              <a:t>Current gold price prediction primarily uses traditional statistical methods and elementary machine learning models, such as moving averages and ARIMA, which assume linear and stationary market behavior due to their simplicity and interpretability.</a:t>
-            </a:r>
-            <a:endParaRPr lang="en-US" altLang="en-US" sz="2000" dirty="0">
-              <a:latin typeface="Times New Roman" panose="02020603050405020304" pitchFamily="18" charset="0"/>
-              <a:ea typeface="Times New Roman" panose="02020603050405020304" pitchFamily="18" charset="0"/>
-            </a:endParaRPr>
-          </a:p>
-          <a:p>
-            <a:r>
-              <a:rPr lang="en-US" altLang="en-US" sz="2000" dirty="0">
-                <a:latin typeface="Times New Roman" panose="02020603050405020304" pitchFamily="18" charset="0"/>
-                <a:ea typeface="Times New Roman" panose="02020603050405020304" pitchFamily="18" charset="0"/>
-              </a:rPr>
-              <a:t>These legacy approaches suffer from significant limitations, including manual and repetitive data gathering, non-automated model retraining, and a high risk of human error, consuming valuable time and resources.</a:t>
-            </a:r>
-            <a:endParaRPr lang="en-US" altLang="en-US" sz="2000" dirty="0">
-              <a:latin typeface="Times New Roman" panose="02020603050405020304" pitchFamily="18" charset="0"/>
-              <a:ea typeface="Times New Roman" panose="02020603050405020304" pitchFamily="18" charset="0"/>
-            </a:endParaRPr>
-          </a:p>
-          <a:p>
-            <a:r>
-              <a:rPr lang="en-US" altLang="en-US" sz="2000" dirty="0">
-                <a:latin typeface="Times New Roman" panose="02020603050405020304" pitchFamily="18" charset="0"/>
-                <a:ea typeface="Times New Roman" panose="02020603050405020304" pitchFamily="18" charset="0"/>
-              </a:rPr>
-              <a:t>Furthermore, these methods are generally limited to short-term forecasts, perform poorly in volatile markets, lack robustness against unexpected events, and are unsuitable for handling increasing data volumes or providing meaningful visualization and decision support.</a:t>
-            </a:r>
-            <a:endParaRPr lang="en-US" altLang="en-US" sz="2000" dirty="0">
-              <a:latin typeface="Times New Roman" panose="02020603050405020304" pitchFamily="18" charset="0"/>
-              <a:ea typeface="Times New Roman" panose="02020603050405020304" pitchFamily="18" charset="0"/>
-            </a:endParaRPr>
-          </a:p>
-        </p:txBody>
-      </p:sp>
-      <p:sp>
-        <p:nvSpPr>
-          <p:cNvPr id="4" name="Slide Number Placeholder 3"/>
-          <p:cNvSpPr txBox="1">
-            <a:spLocks noGrp="1"/>
-          </p:cNvSpPr>
-          <p:nvPr>
-            <p:ph type="sldNum" sz="quarter" idx="12"/>
-          </p:nvPr>
-        </p:nvSpPr>
-        <p:spPr>
-          <a:noFill/>
-        </p:spPr>
-        <p:txBody>
-          <a:bodyPr vert="horz" lIns="91440" tIns="45720" rIns="91440" bIns="45720" rtlCol="0" anchor="ctr"/>
-          <a:lstStyle>
-            <a:lvl1pPr marL="0" lvl="0" indent="0" algn="l" defTabSz="914400" rtl="0" eaLnBrk="1" fontAlgn="base" latinLnBrk="0" hangingPunct="1">
-              <a:lnSpc>
-                <a:spcPct val="100000"/>
-              </a:lnSpc>
-              <a:spcBef>
-                <a:spcPct val="0"/>
-              </a:spcBef>
-              <a:spcAft>
-                <a:spcPct val="0"/>
-              </a:spcAft>
-              <a:buNone/>
-              <a:defRPr sz="1800" b="0" i="0" u="none" kern="1200" baseline="0">
-                <a:solidFill>
-                  <a:schemeClr val="tx1"/>
-                </a:solidFill>
-                <a:latin typeface="Calibri" panose="020F0502020204030204" pitchFamily="34" charset="0"/>
-              </a:defRPr>
-            </a:lvl1pPr>
-            <a:lvl2pPr marL="457200" lvl="1" indent="0" algn="l" defTabSz="914400" rtl="0" eaLnBrk="1" fontAlgn="base" latinLnBrk="0" hangingPunct="1">
-              <a:lnSpc>
-                <a:spcPct val="100000"/>
-              </a:lnSpc>
-              <a:spcBef>
-                <a:spcPct val="0"/>
-              </a:spcBef>
-              <a:spcAft>
-                <a:spcPct val="0"/>
-              </a:spcAft>
-              <a:buNone/>
-              <a:defRPr b="0" i="0" u="none" kern="1200" baseline="0">
-                <a:solidFill>
-                  <a:schemeClr val="tx1"/>
-                </a:solidFill>
-                <a:latin typeface="Arial" panose="020B0604020202020204" pitchFamily="34" charset="0"/>
-                <a:ea typeface="Arial" panose="020B0604020202020204" pitchFamily="34" charset="0"/>
-                <a:cs typeface="+mn-cs"/>
-              </a:defRPr>
-            </a:lvl2pPr>
-            <a:lvl3pPr marL="914400" lvl="2" indent="0" algn="l" defTabSz="914400" rtl="0" eaLnBrk="1" fontAlgn="base" latinLnBrk="0" hangingPunct="1">
-              <a:lnSpc>
-                <a:spcPct val="100000"/>
-              </a:lnSpc>
-              <a:spcBef>
-                <a:spcPct val="0"/>
-              </a:spcBef>
-              <a:spcAft>
-                <a:spcPct val="0"/>
-              </a:spcAft>
-              <a:buNone/>
-              <a:defRPr b="0" i="0" u="none" kern="1200" baseline="0">
-                <a:solidFill>
-                  <a:schemeClr val="tx1"/>
-                </a:solidFill>
-                <a:latin typeface="Arial" panose="020B0604020202020204" pitchFamily="34" charset="0"/>
-                <a:ea typeface="Arial" panose="020B0604020202020204" pitchFamily="34" charset="0"/>
-                <a:cs typeface="+mn-cs"/>
-              </a:defRPr>
-            </a:lvl3pPr>
-            <a:lvl4pPr marL="1371600" lvl="3" indent="0" algn="l" defTabSz="914400" rtl="0" eaLnBrk="1" fontAlgn="base" latinLnBrk="0" hangingPunct="1">
-              <a:lnSpc>
-                <a:spcPct val="100000"/>
-              </a:lnSpc>
-              <a:spcBef>
-                <a:spcPct val="0"/>
-              </a:spcBef>
-              <a:spcAft>
-                <a:spcPct val="0"/>
-              </a:spcAft>
-              <a:buNone/>
-              <a:defRPr b="0" i="0" u="none" kern="1200" baseline="0">
-                <a:solidFill>
-                  <a:schemeClr val="tx1"/>
-                </a:solidFill>
-                <a:latin typeface="Arial" panose="020B0604020202020204" pitchFamily="34" charset="0"/>
-                <a:ea typeface="Arial" panose="020B0604020202020204" pitchFamily="34" charset="0"/>
-                <a:cs typeface="+mn-cs"/>
-              </a:defRPr>
-            </a:lvl4pPr>
-            <a:lvl5pPr marL="1828800" lvl="4" indent="0" algn="l" defTabSz="914400" rtl="0" eaLnBrk="1" fontAlgn="base" latinLnBrk="0" hangingPunct="1">
-              <a:lnSpc>
-                <a:spcPct val="100000"/>
-              </a:lnSpc>
-              <a:spcBef>
-                <a:spcPct val="0"/>
-              </a:spcBef>
-              <a:spcAft>
-                <a:spcPct val="0"/>
-              </a:spcAft>
-              <a:buNone/>
-              <a:defRPr b="0" i="0" u="none" kern="1200" baseline="0">
-                <a:solidFill>
-                  <a:schemeClr val="tx1"/>
-                </a:solidFill>
-                <a:latin typeface="Arial" panose="020B0604020202020204" pitchFamily="34" charset="0"/>
-                <a:ea typeface="Arial" panose="020B0604020202020204" pitchFamily="34" charset="0"/>
-                <a:cs typeface="+mn-cs"/>
-              </a:defRPr>
-            </a:lvl5pPr>
-          </a:lstStyle>
-          <a:p>
-            <a:pPr lvl="0" algn="r">
-              <a:buNone/>
-            </a:pPr>
-            <a:fld id="{9A0DB2DC-4C9A-4742-B13C-FB6460FD3503}" type="slidenum">
-              <a:rPr lang="en-IN" altLang="x-none" sz="1200" dirty="0">
-                <a:solidFill>
-                  <a:srgbClr val="898989"/>
-                </a:solidFill>
-              </a:rPr>
-            </a:fld>
-            <a:endParaRPr lang="en-IN" altLang="x-none" sz="1200" dirty="0">
-              <a:solidFill>
-                <a:srgbClr val="898989"/>
-              </a:solidFill>
-            </a:endParaRPr>
-          </a:p>
-        </p:txBody>
-      </p:sp>
-      <p:pic>
-        <p:nvPicPr>
-          <p:cNvPr id="10245" name="Picture 6"/>
-          <p:cNvPicPr>
-            <a:picLocks noChangeAspect="1"/>
-          </p:cNvPicPr>
-          <p:nvPr/>
-        </p:nvPicPr>
-        <p:blipFill>
-          <a:blip r:embed="rId1"/>
-          <a:stretch>
-            <a:fillRect/>
-          </a:stretch>
-        </p:blipFill>
-        <p:spPr>
-          <a:xfrm>
-            <a:off x="28575" y="5676900"/>
-            <a:ext cx="12163425" cy="1181100"/>
           </a:xfrm>
           <a:prstGeom prst="rect">
             <a:avLst/>

</xml_diff>